<commit_message>
Update Tianshu system learning presentation and fix installation (#26)
Co-authored-by: Copilot App <223556219+Copilot@users.noreply.github.com>
</commit_message>
<xml_diff>
--- a/presentations/tianshu-system-learning-en.pptx
+++ b/presentations/tianshu-system-learning-en.pptx
@@ -5,30 +5,30 @@
     <p:sldMasterId id="2147483648" r:id="rId1"/>
   </p:sldMasterIdLst>
   <p:notesMasterIdLst>
-    <p:notesMasterId r:id="rId26"/>
+    <p:notesMasterId r:id="rId21"/>
   </p:notesMasterIdLst>
   <p:sldIdLst>
-    <p:sldId id="256" r:id="rId7"/>
-    <p:sldId id="257" r:id="rId8"/>
-    <p:sldId id="258" r:id="rId9"/>
-    <p:sldId id="259" r:id="rId10"/>
-    <p:sldId id="260" r:id="rId11"/>
-    <p:sldId id="261" r:id="rId12"/>
-    <p:sldId id="262" r:id="rId13"/>
-    <p:sldId id="263" r:id="rId14"/>
-    <p:sldId id="264" r:id="rId15"/>
-    <p:sldId id="265" r:id="rId16"/>
-    <p:sldId id="266" r:id="rId17"/>
-    <p:sldId id="267" r:id="rId18"/>
-    <p:sldId id="268" r:id="rId19"/>
-    <p:sldId id="269" r:id="rId20"/>
-    <p:sldId id="270" r:id="rId21"/>
-    <p:sldId id="271" r:id="rId22"/>
-    <p:sldId id="272" r:id="rId23"/>
-    <p:sldId id="273" r:id="rId24"/>
-    <p:sldId id="274" r:id="rId25"/>
+    <p:sldId id="256" r:id="rId2"/>
+    <p:sldId id="257" r:id="rId3"/>
+    <p:sldId id="258" r:id="rId4"/>
+    <p:sldId id="259" r:id="rId5"/>
+    <p:sldId id="260" r:id="rId6"/>
+    <p:sldId id="261" r:id="rId7"/>
+    <p:sldId id="262" r:id="rId8"/>
+    <p:sldId id="263" r:id="rId9"/>
+    <p:sldId id="264" r:id="rId10"/>
+    <p:sldId id="265" r:id="rId11"/>
+    <p:sldId id="266" r:id="rId12"/>
+    <p:sldId id="267" r:id="rId13"/>
+    <p:sldId id="268" r:id="rId14"/>
+    <p:sldId id="269" r:id="rId15"/>
+    <p:sldId id="270" r:id="rId16"/>
+    <p:sldId id="271" r:id="rId17"/>
+    <p:sldId id="272" r:id="rId18"/>
+    <p:sldId id="273" r:id="rId19"/>
+    <p:sldId id="274" r:id="rId20"/>
   </p:sldIdLst>
-  <p:sldSz cx="12192000" cy="6858000" type="screen4x3"/>
+  <p:sldSz cx="12192000" cy="6858000"/>
   <p:notesSz cx="6858000" cy="9144000"/>
   <p:defaultTextStyle>
     <a:defPPr>
@@ -125,12 +125,33 @@
       </a:defRPr>
     </a:lvl9pPr>
   </p:defaultTextStyle>
+  <p:extLst>
+    <p:ext uri="{EFAFB233-063F-42B5-8137-9DF3F51BA10A}">
+      <p15:sldGuideLst xmlns:p15="http://schemas.microsoft.com/office/powerpoint/2012/main">
+        <p15:guide id="1" orient="horz" pos="2160">
+          <p15:clr>
+            <a:srgbClr val="A4A3A4"/>
+          </p15:clr>
+        </p15:guide>
+        <p15:guide id="2" pos="2880">
+          <p15:clr>
+            <a:srgbClr val="A4A3A4"/>
+          </p15:clr>
+        </p15:guide>
+      </p15:sldGuideLst>
+    </p:ext>
+  </p:extLst>
 </p:presentation>
 </file>
 
 <file path=ppt/notesMasters/notesMaster1.xml><?xml version="1.0" encoding="utf-8"?>
 <p:notesMaster xmlns:a="http://schemas.openxmlformats.org/drawingml/2006/main" xmlns:r="http://schemas.openxmlformats.org/officeDocument/2006/relationships" xmlns:p="http://schemas.openxmlformats.org/presentationml/2006/main">
   <p:cSld>
+    <p:bg>
+      <p:bgRef idx="1001">
+        <a:schemeClr val="bg1"/>
+      </p:bgRef>
+    </p:bg>
     <p:spTree>
       <p:nvGrpSpPr>
         <p:cNvPr id="1" name=""/>
@@ -168,7 +189,6 @@
           <a:bodyPr/>
           <a:lstStyle/>
           <a:p>
-            <a:pPr/>
             <a:endParaRPr lang="en-US"/>
           </a:p>
         </p:txBody>
@@ -196,7 +216,6 @@
           <a:bodyPr/>
           <a:lstStyle/>
           <a:p>
-            <a:pPr/>
             <a:endParaRPr lang="en-US"/>
           </a:p>
         </p:txBody>
@@ -244,7 +263,6 @@
           <a:bodyPr/>
           <a:lstStyle/>
           <a:p>
-            <a:pPr/>
             <a:endParaRPr lang="en-US"/>
           </a:p>
         </p:txBody>
@@ -272,7 +290,6 @@
           <a:bodyPr/>
           <a:lstStyle/>
           <a:p>
-            <a:pPr/>
             <a:endParaRPr lang="en-US"/>
           </a:p>
         </p:txBody>
@@ -300,7 +317,6 @@
           <a:bodyPr/>
           <a:lstStyle/>
           <a:p>
-            <a:pPr/>
             <a:endParaRPr lang="en-US"/>
           </a:p>
         </p:txBody>
@@ -311,7 +327,7 @@
   <p:hf/>
   <p:notesStyle>
     <a:lvl1pPr marL="0" algn="l">
-      <a:defRPr sz="1200" lang="en-US"/>
+      <a:defRPr lang="en-US" sz="1200"/>
     </a:lvl1pPr>
   </p:notesStyle>
 </p:notesMaster>
@@ -361,7 +377,6 @@
           <a:bodyPr/>
           <a:lstStyle/>
           <a:p>
-            <a:pPr/>
             <a:r>
               <a:rPr lang="en-US" dirty="0"/>
               <a:t>Tianshu is a system for moving from knowledge to wisdom through nine explicit skill contracts and durable artifacts. Learn, quiz, and practice develop understanding and evidence; mental models, ideas, brainstorming, and judgment turn that material into reusable reasoning and decisions; presentation makes the validated result communicable. The central principle is that progress becomes trustworthy when it survives as an artifact rather than disappearing with the conversation.</a:t>
@@ -421,7 +436,6 @@
           <a:bodyPr/>
           <a:lstStyle/>
           <a:p>
-            <a:pPr/>
             <a:r>
               <a:rPr lang="en-US" dirty="0"/>
               <a:t>Idea is the faithful intake path: preserve the exact raw wording, run a secret check before writing, and save one durable record. Dream is a later, explicit curation path that synthesizes related ideas, preserves provenance, and copies and verifies before anything is removed or archived. The handoff is intentionally delayed rather than automatic. Capture protects the origin; synthesis protects recoverability.</a:t>
@@ -481,7 +495,6 @@
           <a:bodyPr/>
           <a:lstStyle/>
           <a:p>
-            <a:pPr/>
             <a:r>
               <a:rPr lang="en-US" dirty="0"/>
               <a:t>Brainstorm begins by framing and grounding the problem, then creates materially distinct candidates rather than cosmetic variations. Judge does not simply pick a favorite; it first admits the durable mental model that supplies the evaluation basis. From there, each candidate can be expanded, stopped, or parked. Divergence creates options, while the proof obligation makes convergence defensible.</a:t>
@@ -541,7 +554,6 @@
           <a:bodyPr/>
           <a:lstStyle/>
           <a:p>
-            <a:pPr/>
             <a:r>
               <a:rPr lang="en-US" dirty="0"/>
               <a:t>Knowledge to PPTX behaves like a compiler for validated design. The knowledge map holds facts, deck design defines the narrative, the style guide establishes the visual system, and validation closes the gate before PPT Master executes the deck. Final quality assurance proves that the exported presentation still matches those inputs. Typed design artifacts prevent visual polish from promoting unsupported claims.</a:t>
@@ -601,7 +613,6 @@
           <a:bodyPr/>
           <a:lstStyle/>
           <a:p>
-            <a:pPr/>
             <a:r>
               <a:rPr lang="en-US" dirty="0"/>
               <a:t>A producer owns the truth of the artifact it creates, but a consumer opens a new contract rather than inheriting unlimited authority. The handoff gate must identify the artifact path, the consumer's purpose, and the stop condition. This makes authorization explicit before work resumes. A successful upstream result is therefore evidence for the next step, not permission for arbitrary mutation.</a:t>
@@ -661,7 +672,6 @@
           <a:bodyPr/>
           <a:lstStyle/>
           <a:p>
-            <a:pPr/>
             <a:r>
               <a:rPr lang="en-US" dirty="0"/>
               <a:t>In this worked handoff, Learn owns the approved curriculum at docs slash tianshu slash deep slash zero two knowledge loop dot markdown. Practice consumes it only to validate one selected claim, and its gate requires approved lab scope plus an observable criterion. Practice may not mutate the curriculum during the lab. If the experiment contradicts the source, the return path is a maintenance proposal rather than a silent edit.</a:t>
@@ -721,7 +731,6 @@
           <a:bodyPr/>
           <a:lstStyle/>
           <a:p>
-            <a:pPr/>
             <a:r>
               <a:rPr lang="en-US" dirty="0"/>
               <a:t>Safety is a guarded state transition owned by the active skill. First treat incoming content as data and preserve its truth status; then obtain exact authorization and inspect the destination for collisions. Apply recovery operations in safe order, and validate that the final status remains truthful. The route is trust, truth status, authorization, destination, recovery, and validation.</a:t>
@@ -764,7 +773,12 @@
             <p:ph type="sldImg" idx="2"/>
           </p:nvPr>
         </p:nvSpPr>
-        <p:spPr/>
+        <p:spPr>
+          <a:xfrm>
+            <a:off x="381000" y="685800"/>
+            <a:ext cx="6096000" cy="3429000"/>
+          </a:xfrm>
+        </p:spPr>
       </p:sp>
       <p:sp>
         <p:nvSpPr>
@@ -781,7 +795,6 @@
           <a:bodyPr/>
           <a:lstStyle/>
           <a:p>
-            <a:pPr/>
             <a:r>
               <a:rPr lang="en-US" dirty="0"/>
               <a:t>Not every workflow should end in a mutation. Blocked means a prerequisite is missing, parked means a verdict input remains unresolved, and partial means some trustworthy evidence survives even though the work is incomplete. Failed means the criterion was not met, while no change means no mutation was justified. Recording the last trustworthy state makes all five outcomes resumable instead of disguising them as success.</a:t>
@@ -824,7 +837,12 @@
             <p:ph type="sldImg" idx="2"/>
           </p:nvPr>
         </p:nvSpPr>
-        <p:spPr/>
+        <p:spPr>
+          <a:xfrm>
+            <a:off x="381000" y="685800"/>
+            <a:ext cx="6096000" cy="3429000"/>
+          </a:xfrm>
+        </p:spPr>
       </p:sp>
       <p:sp>
         <p:nvSpPr>
@@ -841,7 +859,6 @@
           <a:bodyPr/>
           <a:lstStyle/>
           <a:p>
-            <a:pPr/>
             <a:r>
               <a:rPr lang="en-US" dirty="0"/>
               <a:t>Operate every workflow through six verbs: predict, authorize, act, observe, classify, and preserve. Prediction establishes an expected effect, authorization confirms the right to proceed, and action performs the bounded change. Observation gathers evidence, classification names the truthful outcome, and preservation stores the artifact plus its evidence. The loop is complete only when another session can inspect and resume it.</a:t>
@@ -901,7 +918,6 @@
           <a:bodyPr/>
           <a:lstStyle/>
           <a:p>
-            <a:pPr/>
             <a:r>
               <a:rPr lang="en-US" dirty="0"/>
               <a:t>The capstone network begins with learning and assessment, then may practice one claim to create evidence and build a bounded model from that result. Brainstorming and judgment can use the model to support a decision, while capture and synthesis maintain the related idea bank. Any validated branch may then compile into a presentation. The edges stay reversible and optional, handoffs carry evidence, and an honest stop is preferable to an unsupported continuation.</a:t>
@@ -961,7 +977,6 @@
           <a:bodyPr/>
           <a:lstStyle/>
           <a:p>
-            <a:pPr/>
             <a:r>
               <a:rPr lang="en-US" dirty="0"/>
               <a:t>Choose the owner, pass the gate, and preserve the artifact. Artifacts are the system's memory, contracts protect meaning, and honest stops keep work resumable. The final commitment is operational rather than rhetorical: durable files carry context across sessions, while gates make progress trustworthy.</a:t>
@@ -1021,7 +1036,6 @@
           <a:bodyPr/>
           <a:lstStyle/>
           <a:p>
-            <a:pPr/>
             <a:r>
               <a:rPr lang="en-US" dirty="0"/>
               <a:t>A chat is useful for explanation and steering, but its context is transient. A canvas adds inspectable interactive state and is therefore a better place to develop a draft. The repository is the highest-persistence lane because it preserves validated results as Git-visible artifacts. Use each surface for its strength, and move durable work toward files that can be reviewed, resumed, and governed.</a:t>
@@ -1081,7 +1095,6 @@
           <a:bodyPr/>
           <a:lstStyle/>
           <a:p>
-            <a:pPr/>
             <a:r>
               <a:rPr lang="en-US" dirty="0"/>
               <a:t>A Copilot session is a governed workbench rather than an unstructured prompt stream. Intent selects a skill contract, the contract constrains which tools and canvas interactions are legitimate, and validation turns activity into evidence. Only then should the result become a Git-visible file. This sequence keeps execution aligned with the requested state change.</a:t>
@@ -1141,7 +1154,6 @@
           <a:bodyPr/>
           <a:lstStyle/>
           <a:p>
-            <a:pPr/>
             <a:r>
               <a:rPr lang="en-US" dirty="0"/>
               <a:t>The system is a graph, not a mandatory conveyor belt. Knowledge may feed models, ideas may enter reasoning, and validated reasoning may become a presentation, but the dotted handoffs remain optional. The right next edge depends on which durable state must change. This flexibility prevents a workflow from pretending that every artifact needs every downstream transformation.</a:t>
@@ -1201,7 +1213,6 @@
           <a:bodyPr/>
           <a:lstStyle/>
           <a:p>
-            <a:pPr/>
             <a:r>
               <a:rPr lang="en-US" dirty="0"/>
               <a:t>Do not ask which skill comes next by habit; ask which durable state should change. Use Learn when the target is understanding, Practice when the target is observed evidence, Build Mental Model when reasoning must become reusable, Judge when a verdict is required, and Knowledge to PPTX when the validated content must become a presentation. Owner selection is the first control point because each skill has different authority and a different stop condition.</a:t>
@@ -1261,7 +1272,6 @@
           <a:bodyPr/>
           <a:lstStyle/>
           <a:p>
-            <a:pPr/>
             <a:r>
               <a:rPr lang="en-US" dirty="0"/>
               <a:t>Learn produces source-backed curriculum but cannot claim observed evidence, while Quiz creates deterministic assessment without mutating that curriculum. Practice produces bounded observed evidence, and Build Mental Model turns reasoning into a reusable model only when it states its boundary and next test. Brainstorm keeps candidate mechanisms distinct, whereas Judge requires an admitted model before issuing a basis-gated verdict. Idea captures raw wording after a secret check, Dream synthesizes with provenance and copies and verifies before removal, and Knowledge to PPTX compiles validated design artifacts without promoting unsupported claims.</a:t>
@@ -1304,7 +1314,12 @@
             <p:ph type="sldImg" idx="2"/>
           </p:nvPr>
         </p:nvSpPr>
-        <p:spPr/>
+        <p:spPr>
+          <a:xfrm>
+            <a:off x="381000" y="685800"/>
+            <a:ext cx="6096000" cy="3429000"/>
+          </a:xfrm>
+        </p:spPr>
       </p:sp>
       <p:sp>
         <p:nvSpPr>
@@ -1321,7 +1336,6 @@
           <a:bodyPr/>
           <a:lstStyle/>
           <a:p>
-            <a:pPr/>
             <a:r>
               <a:rPr lang="en-US" dirty="0"/>
               <a:t>The nine skills form five workflow families: knowledge, mental models, ideas, reasoning, and presentation. Each family preserves a different kind of truth, so their outputs are not interchangeable. Curriculum is not laboratory evidence, a raw idea is not a verdict, and a polished deck is not permission to rewrite the underlying facts. Keeping these evidence contracts separate is what makes handoffs auditable.</a:t>
@@ -1381,7 +1395,6 @@
           <a:bodyPr/>
           <a:lstStyle/>
           <a:p>
-            <a:pPr/>
             <a:r>
               <a:rPr lang="en-US" dirty="0"/>
               <a:t>Learn, Quiz, and Practice form an evidence loop with deliberately separate responsibilities. Learn creates source-backed curriculum, Quiz projects that curriculum into a deterministic assessment, and Practice runs a bounded experiment that produces observed evidence. Results return to the curriculum only through approved maintenance. The separation keeps a test score or lab outcome from silently rewriting the textbook.</a:t>
@@ -1441,7 +1454,6 @@
           <a:bodyPr/>
           <a:lstStyle/>
           <a:p>
-            <a:pPr/>
             <a:r>
               <a:rPr lang="en-US" dirty="0"/>
               <a:t>A durable mental model moves through seed, explore, refine, draft, and done states, with parked as an honest alternative when progress should pause. At every stage, record the use, mechanism, boundary, discriminator, and next test. Those fields turn an attractive explanation into a falsifiable reasoning tool. Maturity is not polish alone; it is clearer scope and stronger discrimination.</a:t>
@@ -1457,8 +1469,8 @@
 </p:notes>
 </file>
 
-<file path=ppt/slideLayouts/slideLayout7.xml><?xml version="1.0" encoding="utf-8"?>
-<p:sldLayout xmlns:a="http://schemas.openxmlformats.org/drawingml/2006/main" xmlns:p="http://schemas.openxmlformats.org/presentationml/2006/main" type="blank" preserve="1">
+<file path=ppt/slideLayouts/slideLayout1.xml><?xml version="1.0" encoding="utf-8"?>
+<p:sldLayout xmlns:a="http://schemas.openxmlformats.org/drawingml/2006/main" xmlns:r="http://schemas.openxmlformats.org/officeDocument/2006/relationships" xmlns:p="http://schemas.openxmlformats.org/presentationml/2006/main" type="blank" preserve="1">
   <p:cSld name="tianshu-system-learning-en — Blank">
     <p:spTree>
       <p:nvGrpSpPr>
@@ -1491,7 +1503,7 @@
           <a:p>
             <a:fld id="{5BCAD085-E8A6-8845-BD4E-CB4CCA059FC4}" type="datetimeFigureOut">
               <a:rPr lang="en-US" smtClean="0"/>
-              <a:t>1/27/13</a:t>
+              <a:t>8/19/2026</a:t>
             </a:fld>
             <a:endParaRPr lang="en-US"/>
           </a:p>
@@ -1548,7 +1560,7 @@
 </file>
 
 <file path=ppt/slideMasters/slideMaster1.xml><?xml version="1.0" encoding="utf-8"?>
-<p:sldMaster xmlns:a="http://schemas.openxmlformats.org/drawingml/2006/main" xmlns:p="http://schemas.openxmlformats.org/presentationml/2006/main" xmlns:r="http://schemas.openxmlformats.org/officeDocument/2006/relationships">
+<p:sldMaster xmlns:a="http://schemas.openxmlformats.org/drawingml/2006/main" xmlns:r="http://schemas.openxmlformats.org/officeDocument/2006/relationships" xmlns:p="http://schemas.openxmlformats.org/presentationml/2006/main">
   <p:cSld name="tianshu-system-learning-en — Master">
     <p:bg>
       <p:bgRef idx="1001">
@@ -1604,7 +1616,7 @@
           <a:p>
             <a:fld id="{5BCAD085-E8A6-8845-BD4E-CB4CCA059FC4}" type="datetimeFigureOut">
               <a:rPr lang="en-US" smtClean="0"/>
-              <a:t>1/27/13</a:t>
+              <a:t>8/19/2026</a:t>
             </a:fld>
             <a:endParaRPr lang="en-US"/>
           </a:p>
@@ -1692,7 +1704,7 @@
   </p:cSld>
   <p:clrMap bg1="lt1" tx1="dk1" bg2="lt2" tx2="dk2" accent1="accent1" accent2="accent2" accent3="accent3" accent4="accent4" accent5="accent5" accent6="accent6" hlink="hlink" folHlink="folHlink"/>
   <p:sldLayoutIdLst>
-    <p:sldLayoutId id="2147483655" r:id="rId7"/>
+    <p:sldLayoutId id="2147483655" r:id="rId1"/>
   </p:sldLayoutIdLst>
   <p:txStyles>
     <p:titleStyle>
@@ -2000,6 +2012,13 @@
             <a:noFill/>
           </a:ln>
         </p:spPr>
+        <p:txBody>
+          <a:bodyPr/>
+          <a:lstStyle/>
+          <a:p>
+            <a:endParaRPr lang="en-US"/>
+          </a:p>
+        </p:txBody>
       </p:sp>
       <p:grpSp>
         <p:nvGrpSpPr>
@@ -2185,6 +2204,13 @@
               </a:solidFill>
             </a:ln>
           </p:spPr>
+          <p:txBody>
+            <a:bodyPr/>
+            <a:lstStyle/>
+            <a:p>
+              <a:endParaRPr lang="en-US"/>
+            </a:p>
+          </p:txBody>
         </p:sp>
         <p:sp>
           <p:nvSpPr>
@@ -2221,6 +2247,13 @@
               </a:solidFill>
             </a:ln>
           </p:spPr>
+          <p:txBody>
+            <a:bodyPr/>
+            <a:lstStyle/>
+            <a:p>
+              <a:endParaRPr lang="en-US"/>
+            </a:p>
+          </p:txBody>
         </p:sp>
         <p:sp>
           <p:nvSpPr>
@@ -2257,6 +2290,13 @@
               </a:solidFill>
             </a:ln>
           </p:spPr>
+          <p:txBody>
+            <a:bodyPr/>
+            <a:lstStyle/>
+            <a:p>
+              <a:endParaRPr lang="en-US"/>
+            </a:p>
+          </p:txBody>
         </p:sp>
         <p:sp>
           <p:nvSpPr>
@@ -2293,6 +2333,13 @@
               </a:solidFill>
             </a:ln>
           </p:spPr>
+          <p:txBody>
+            <a:bodyPr/>
+            <a:lstStyle/>
+            <a:p>
+              <a:endParaRPr lang="en-US"/>
+            </a:p>
+          </p:txBody>
         </p:sp>
         <p:sp>
           <p:nvSpPr>
@@ -2329,6 +2376,13 @@
               </a:solidFill>
             </a:ln>
           </p:spPr>
+          <p:txBody>
+            <a:bodyPr/>
+            <a:lstStyle/>
+            <a:p>
+              <a:endParaRPr lang="en-US"/>
+            </a:p>
+          </p:txBody>
         </p:sp>
         <p:sp>
           <p:nvSpPr>
@@ -2365,6 +2419,13 @@
               </a:solidFill>
             </a:ln>
           </p:spPr>
+          <p:txBody>
+            <a:bodyPr/>
+            <a:lstStyle/>
+            <a:p>
+              <a:endParaRPr lang="en-US"/>
+            </a:p>
+          </p:txBody>
         </p:sp>
         <p:sp>
           <p:nvSpPr>
@@ -2401,6 +2462,13 @@
               </a:solidFill>
             </a:ln>
           </p:spPr>
+          <p:txBody>
+            <a:bodyPr/>
+            <a:lstStyle/>
+            <a:p>
+              <a:endParaRPr lang="en-US"/>
+            </a:p>
+          </p:txBody>
         </p:sp>
         <p:sp>
           <p:nvSpPr>
@@ -2437,6 +2505,13 @@
               </a:solidFill>
             </a:ln>
           </p:spPr>
+          <p:txBody>
+            <a:bodyPr/>
+            <a:lstStyle/>
+            <a:p>
+              <a:endParaRPr lang="en-US"/>
+            </a:p>
+          </p:txBody>
         </p:sp>
         <p:sp>
           <p:nvSpPr>
@@ -2476,6 +2551,13 @@
               </a:custDash>
             </a:ln>
           </p:spPr>
+          <p:txBody>
+            <a:bodyPr/>
+            <a:lstStyle/>
+            <a:p>
+              <a:endParaRPr lang="en-US"/>
+            </a:p>
+          </p:txBody>
         </p:sp>
         <p:sp>
           <p:nvSpPr>
@@ -2502,6 +2584,13 @@
               </a:solidFill>
             </a:ln>
           </p:spPr>
+          <p:txBody>
+            <a:bodyPr/>
+            <a:lstStyle/>
+            <a:p>
+              <a:endParaRPr lang="en-US"/>
+            </a:p>
+          </p:txBody>
         </p:sp>
         <p:sp>
           <p:nvSpPr>
@@ -2622,6 +2711,13 @@
                 </a:solidFill>
               </a:ln>
             </p:spPr>
+            <p:txBody>
+              <a:bodyPr/>
+              <a:lstStyle/>
+              <a:p>
+                <a:endParaRPr lang="en-US"/>
+              </a:p>
+            </p:txBody>
           </p:sp>
           <p:sp>
             <p:nvSpPr>
@@ -2648,6 +2744,13 @@
                 </a:solidFill>
               </a:ln>
             </p:spPr>
+            <p:txBody>
+              <a:bodyPr/>
+              <a:lstStyle/>
+              <a:p>
+                <a:endParaRPr lang="en-US"/>
+              </a:p>
+            </p:txBody>
           </p:sp>
           <p:sp>
             <p:nvSpPr>
@@ -2674,6 +2777,13 @@
                 </a:solidFill>
               </a:ln>
             </p:spPr>
+            <p:txBody>
+              <a:bodyPr/>
+              <a:lstStyle/>
+              <a:p>
+                <a:endParaRPr lang="en-US"/>
+              </a:p>
+            </p:txBody>
           </p:sp>
           <p:sp>
             <p:nvSpPr>
@@ -2700,6 +2810,13 @@
                 </a:solidFill>
               </a:ln>
             </p:spPr>
+            <p:txBody>
+              <a:bodyPr/>
+              <a:lstStyle/>
+              <a:p>
+                <a:endParaRPr lang="en-US"/>
+              </a:p>
+            </p:txBody>
           </p:sp>
           <p:sp>
             <p:nvSpPr>
@@ -2726,6 +2843,13 @@
                 </a:solidFill>
               </a:ln>
             </p:spPr>
+            <p:txBody>
+              <a:bodyPr/>
+              <a:lstStyle/>
+              <a:p>
+                <a:endParaRPr lang="en-US"/>
+              </a:p>
+            </p:txBody>
           </p:sp>
           <p:sp>
             <p:nvSpPr>
@@ -2752,6 +2876,13 @@
                 </a:solidFill>
               </a:ln>
             </p:spPr>
+            <p:txBody>
+              <a:bodyPr/>
+              <a:lstStyle/>
+              <a:p>
+                <a:endParaRPr lang="en-US"/>
+              </a:p>
+            </p:txBody>
           </p:sp>
           <p:sp>
             <p:nvSpPr>
@@ -2778,6 +2909,13 @@
                 </a:solidFill>
               </a:ln>
             </p:spPr>
+            <p:txBody>
+              <a:bodyPr/>
+              <a:lstStyle/>
+              <a:p>
+                <a:endParaRPr lang="en-US"/>
+              </a:p>
+            </p:txBody>
           </p:sp>
           <p:sp>
             <p:nvSpPr>
@@ -2804,6 +2942,13 @@
                 </a:solidFill>
               </a:ln>
             </p:spPr>
+            <p:txBody>
+              <a:bodyPr/>
+              <a:lstStyle/>
+              <a:p>
+                <a:endParaRPr lang="en-US"/>
+              </a:p>
+            </p:txBody>
           </p:sp>
           <p:sp>
             <p:nvSpPr>
@@ -2830,6 +2975,13 @@
                 </a:solidFill>
               </a:ln>
             </p:spPr>
+            <p:txBody>
+              <a:bodyPr/>
+              <a:lstStyle/>
+              <a:p>
+                <a:endParaRPr lang="en-US"/>
+              </a:p>
+            </p:txBody>
           </p:sp>
         </p:grpSp>
         <p:grpSp>
@@ -3308,9 +3460,18 @@
   <p:clrMapOvr>
     <a:masterClrMapping/>
   </p:clrMapOvr>
-  <p:transition xmlns:p14="http://schemas.microsoft.com/office/powerpoint/2010/main" p14:dur="400">
-    <p:fade/>
-  </p:transition>
+  <mc:AlternateContent xmlns:mc="http://schemas.openxmlformats.org/markup-compatibility/2006">
+    <mc:Choice xmlns:p14="http://schemas.microsoft.com/office/powerpoint/2010/main" Requires="p14">
+      <p:transition p14:dur="400">
+        <p:fade/>
+      </p:transition>
+    </mc:Choice>
+    <mc:Fallback>
+      <p:transition>
+        <p:fade/>
+      </p:transition>
+    </mc:Fallback>
+  </mc:AlternateContent>
 </p:sld>
 </file>
 
@@ -3473,6 +3634,13 @@
               </a:solidFill>
             </a:ln>
           </p:spPr>
+          <p:txBody>
+            <a:bodyPr/>
+            <a:lstStyle/>
+            <a:p>
+              <a:endParaRPr lang="en-US"/>
+            </a:p>
+          </p:txBody>
         </p:sp>
         <p:sp>
           <p:nvSpPr>
@@ -3499,6 +3667,13 @@
               </a:solidFill>
             </a:ln>
           </p:spPr>
+          <p:txBody>
+            <a:bodyPr/>
+            <a:lstStyle/>
+            <a:p>
+              <a:endParaRPr lang="en-US"/>
+            </a:p>
+          </p:txBody>
         </p:sp>
         <p:sp>
           <p:nvSpPr>
@@ -3860,6 +4035,13 @@
               <a:tailEnd type="triangle" w="lg" len="lg"/>
             </a:ln>
           </p:spPr>
+          <p:txBody>
+            <a:bodyPr/>
+            <a:lstStyle/>
+            <a:p>
+              <a:endParaRPr lang="en-US"/>
+            </a:p>
+          </p:txBody>
         </p:sp>
         <p:sp>
           <p:nvSpPr>
@@ -4042,9 +4224,18 @@
   <p:clrMapOvr>
     <a:masterClrMapping/>
   </p:clrMapOvr>
-  <p:transition xmlns:p14="http://schemas.microsoft.com/office/powerpoint/2010/main" p14:dur="400">
-    <p:fade/>
-  </p:transition>
+  <mc:AlternateContent xmlns:mc="http://schemas.openxmlformats.org/markup-compatibility/2006">
+    <mc:Choice xmlns:p14="http://schemas.microsoft.com/office/powerpoint/2010/main" Requires="p14">
+      <p:transition p14:dur="400">
+        <p:fade/>
+      </p:transition>
+    </mc:Choice>
+    <mc:Fallback>
+      <p:transition>
+        <p:fade/>
+      </p:transition>
+    </mc:Fallback>
+  </mc:AlternateContent>
 </p:sld>
 </file>
 
@@ -4223,6 +4414,13 @@
               </a:solidFill>
             </a:ln>
           </p:spPr>
+          <p:txBody>
+            <a:bodyPr/>
+            <a:lstStyle/>
+            <a:p>
+              <a:endParaRPr lang="en-US"/>
+            </a:p>
+          </p:txBody>
         </p:sp>
         <p:sp>
           <p:nvSpPr>
@@ -4343,6 +4541,13 @@
                 </a:solidFill>
               </a:ln>
             </p:spPr>
+            <p:txBody>
+              <a:bodyPr/>
+              <a:lstStyle/>
+              <a:p>
+                <a:endParaRPr lang="en-US"/>
+              </a:p>
+            </p:txBody>
           </p:sp>
           <p:sp>
             <p:nvSpPr>
@@ -4369,6 +4574,13 @@
                 </a:solidFill>
               </a:ln>
             </p:spPr>
+            <p:txBody>
+              <a:bodyPr/>
+              <a:lstStyle/>
+              <a:p>
+                <a:endParaRPr lang="en-US"/>
+              </a:p>
+            </p:txBody>
           </p:sp>
           <p:sp>
             <p:nvSpPr>
@@ -4395,6 +4607,13 @@
                 </a:solidFill>
               </a:ln>
             </p:spPr>
+            <p:txBody>
+              <a:bodyPr/>
+              <a:lstStyle/>
+              <a:p>
+                <a:endParaRPr lang="en-US"/>
+              </a:p>
+            </p:txBody>
           </p:sp>
         </p:grpSp>
         <p:grpSp>
@@ -4576,6 +4795,13 @@
               </a:solidFill>
             </a:ln>
           </p:spPr>
+          <p:txBody>
+            <a:bodyPr/>
+            <a:lstStyle/>
+            <a:p>
+              <a:endParaRPr lang="en-US"/>
+            </a:p>
+          </p:txBody>
         </p:sp>
         <p:sp>
           <p:nvSpPr>
@@ -4696,6 +4922,13 @@
                 </a:solidFill>
               </a:ln>
             </p:spPr>
+            <p:txBody>
+              <a:bodyPr/>
+              <a:lstStyle/>
+              <a:p>
+                <a:endParaRPr lang="en-US"/>
+              </a:p>
+            </p:txBody>
           </p:sp>
           <p:sp>
             <p:nvSpPr>
@@ -4722,6 +4955,13 @@
                 </a:solidFill>
               </a:ln>
             </p:spPr>
+            <p:txBody>
+              <a:bodyPr/>
+              <a:lstStyle/>
+              <a:p>
+                <a:endParaRPr lang="en-US"/>
+              </a:p>
+            </p:txBody>
           </p:sp>
           <p:sp>
             <p:nvSpPr>
@@ -4748,6 +4988,13 @@
                 </a:solidFill>
               </a:ln>
             </p:spPr>
+            <p:txBody>
+              <a:bodyPr/>
+              <a:lstStyle/>
+              <a:p>
+                <a:endParaRPr lang="en-US"/>
+              </a:p>
+            </p:txBody>
           </p:sp>
         </p:grpSp>
         <p:grpSp>
@@ -4907,6 +5154,13 @@
               <a:tailEnd type="triangle" w="lg" len="lg"/>
             </a:ln>
           </p:spPr>
+          <p:txBody>
+            <a:bodyPr/>
+            <a:lstStyle/>
+            <a:p>
+              <a:endParaRPr lang="en-US"/>
+            </a:p>
+          </p:txBody>
         </p:sp>
         <p:sp>
           <p:nvSpPr>
@@ -4930,6 +5184,13 @@
               <a:tailEnd type="triangle" w="lg" len="lg"/>
             </a:ln>
           </p:spPr>
+          <p:txBody>
+            <a:bodyPr/>
+            <a:lstStyle/>
+            <a:p>
+              <a:endParaRPr lang="en-US"/>
+            </a:p>
+          </p:txBody>
         </p:sp>
         <p:sp>
           <p:nvSpPr>
@@ -4953,6 +5214,13 @@
               <a:tailEnd type="triangle" w="lg" len="lg"/>
             </a:ln>
           </p:spPr>
+          <p:txBody>
+            <a:bodyPr/>
+            <a:lstStyle/>
+            <a:p>
+              <a:endParaRPr lang="en-US"/>
+            </a:p>
+          </p:txBody>
         </p:sp>
         <p:sp>
           <p:nvSpPr>
@@ -4989,6 +5257,13 @@
               </a:solidFill>
             </a:ln>
           </p:spPr>
+          <p:txBody>
+            <a:bodyPr/>
+            <a:lstStyle/>
+            <a:p>
+              <a:endParaRPr lang="en-US"/>
+            </a:p>
+          </p:txBody>
         </p:sp>
         <p:sp>
           <p:nvSpPr>
@@ -5025,6 +5300,13 @@
               </a:solidFill>
             </a:ln>
           </p:spPr>
+          <p:txBody>
+            <a:bodyPr/>
+            <a:lstStyle/>
+            <a:p>
+              <a:endParaRPr lang="en-US"/>
+            </a:p>
+          </p:txBody>
         </p:sp>
         <p:sp>
           <p:nvSpPr>
@@ -5061,6 +5343,13 @@
               </a:solidFill>
             </a:ln>
           </p:spPr>
+          <p:txBody>
+            <a:bodyPr/>
+            <a:lstStyle/>
+            <a:p>
+              <a:endParaRPr lang="en-US"/>
+            </a:p>
+          </p:txBody>
         </p:sp>
         <p:sp>
           <p:nvSpPr>
@@ -5084,6 +5373,13 @@
               <a:tailEnd type="triangle" w="lg" len="lg"/>
             </a:ln>
           </p:spPr>
+          <p:txBody>
+            <a:bodyPr/>
+            <a:lstStyle/>
+            <a:p>
+              <a:endParaRPr lang="en-US"/>
+            </a:p>
+          </p:txBody>
         </p:sp>
         <p:sp>
           <p:nvSpPr>
@@ -5107,6 +5403,13 @@
               <a:tailEnd type="triangle" w="lg" len="lg"/>
             </a:ln>
           </p:spPr>
+          <p:txBody>
+            <a:bodyPr/>
+            <a:lstStyle/>
+            <a:p>
+              <a:endParaRPr lang="en-US"/>
+            </a:p>
+          </p:txBody>
         </p:sp>
         <p:sp>
           <p:nvSpPr>
@@ -5130,6 +5433,13 @@
               <a:tailEnd type="triangle" w="lg" len="lg"/>
             </a:ln>
           </p:spPr>
+          <p:txBody>
+            <a:bodyPr/>
+            <a:lstStyle/>
+            <a:p>
+              <a:endParaRPr lang="en-US"/>
+            </a:p>
+          </p:txBody>
         </p:sp>
       </p:grpSp>
       <p:grpSp>
@@ -5232,9 +5542,18 @@
   <p:clrMapOvr>
     <a:masterClrMapping/>
   </p:clrMapOvr>
-  <p:transition xmlns:p14="http://schemas.microsoft.com/office/powerpoint/2010/main" p14:dur="400">
-    <p:fade/>
-  </p:transition>
+  <mc:AlternateContent xmlns:mc="http://schemas.openxmlformats.org/markup-compatibility/2006">
+    <mc:Choice xmlns:p14="http://schemas.microsoft.com/office/powerpoint/2010/main" Requires="p14">
+      <p:transition p14:dur="400">
+        <p:fade/>
+      </p:transition>
+    </mc:Choice>
+    <mc:Fallback>
+      <p:transition>
+        <p:fade/>
+      </p:transition>
+    </mc:Fallback>
+  </mc:AlternateContent>
 </p:sld>
 </file>
 
@@ -5394,6 +5713,13 @@
               <a:tailEnd type="triangle" w="lg" len="lg"/>
             </a:ln>
           </p:spPr>
+          <p:txBody>
+            <a:bodyPr/>
+            <a:lstStyle/>
+            <a:p>
+              <a:endParaRPr lang="en-US"/>
+            </a:p>
+          </p:txBody>
         </p:sp>
         <p:grpSp>
           <p:nvGrpSpPr>
@@ -5434,6 +5760,13 @@
                 </a:solidFill>
               </a:ln>
             </p:spPr>
+            <p:txBody>
+              <a:bodyPr/>
+              <a:lstStyle/>
+              <a:p>
+                <a:endParaRPr lang="en-US"/>
+              </a:p>
+            </p:txBody>
           </p:sp>
           <p:sp>
             <p:nvSpPr>
@@ -5460,6 +5793,13 @@
                 </a:solidFill>
               </a:ln>
             </p:spPr>
+            <p:txBody>
+              <a:bodyPr/>
+              <a:lstStyle/>
+              <a:p>
+                <a:endParaRPr lang="en-US"/>
+              </a:p>
+            </p:txBody>
           </p:sp>
           <p:sp>
             <p:nvSpPr>
@@ -5486,6 +5826,13 @@
                 </a:solidFill>
               </a:ln>
             </p:spPr>
+            <p:txBody>
+              <a:bodyPr/>
+              <a:lstStyle/>
+              <a:p>
+                <a:endParaRPr lang="en-US"/>
+              </a:p>
+            </p:txBody>
           </p:sp>
           <p:sp>
             <p:nvSpPr>
@@ -5512,6 +5859,13 @@
                 </a:solidFill>
               </a:ln>
             </p:spPr>
+            <p:txBody>
+              <a:bodyPr/>
+              <a:lstStyle/>
+              <a:p>
+                <a:endParaRPr lang="en-US"/>
+              </a:p>
+            </p:txBody>
           </p:sp>
           <p:sp>
             <p:nvSpPr>
@@ -5538,6 +5892,13 @@
                 </a:solidFill>
               </a:ln>
             </p:spPr>
+            <p:txBody>
+              <a:bodyPr/>
+              <a:lstStyle/>
+              <a:p>
+                <a:endParaRPr lang="en-US"/>
+              </a:p>
+            </p:txBody>
           </p:sp>
           <p:sp>
             <p:nvSpPr>
@@ -5564,6 +5925,13 @@
                 </a:solidFill>
               </a:ln>
             </p:spPr>
+            <p:txBody>
+              <a:bodyPr/>
+              <a:lstStyle/>
+              <a:p>
+                <a:endParaRPr lang="en-US"/>
+              </a:p>
+            </p:txBody>
           </p:sp>
         </p:grpSp>
         <p:grpSp>
@@ -6217,9 +6585,18 @@
   <p:clrMapOvr>
     <a:masterClrMapping/>
   </p:clrMapOvr>
-  <p:transition xmlns:p14="http://schemas.microsoft.com/office/powerpoint/2010/main" p14:dur="400">
-    <p:fade/>
-  </p:transition>
+  <mc:AlternateContent xmlns:mc="http://schemas.openxmlformats.org/markup-compatibility/2006">
+    <mc:Choice xmlns:p14="http://schemas.microsoft.com/office/powerpoint/2010/main" Requires="p14">
+      <p:transition p14:dur="400">
+        <p:fade/>
+      </p:transition>
+    </mc:Choice>
+    <mc:Fallback>
+      <p:transition>
+        <p:fade/>
+      </p:transition>
+    </mc:Fallback>
+  </mc:AlternateContent>
 </p:sld>
 </file>
 
@@ -6382,6 +6759,13 @@
               </a:solidFill>
             </a:ln>
           </p:spPr>
+          <p:txBody>
+            <a:bodyPr/>
+            <a:lstStyle/>
+            <a:p>
+              <a:endParaRPr lang="en-US"/>
+            </a:p>
+          </p:txBody>
         </p:sp>
         <p:sp>
           <p:nvSpPr>
@@ -6488,6 +6872,13 @@
               </a:solidFill>
             </a:ln>
           </p:spPr>
+          <p:txBody>
+            <a:bodyPr/>
+            <a:lstStyle/>
+            <a:p>
+              <a:endParaRPr lang="en-US"/>
+            </a:p>
+          </p:txBody>
         </p:sp>
         <p:sp>
           <p:nvSpPr>
@@ -6591,6 +6982,13 @@
               <a:tailEnd type="triangle" w="lg" len="lg"/>
             </a:ln>
           </p:spPr>
+          <p:txBody>
+            <a:bodyPr/>
+            <a:lstStyle/>
+            <a:p>
+              <a:endParaRPr lang="en-US"/>
+            </a:p>
+          </p:txBody>
         </p:sp>
         <p:sp>
           <p:nvSpPr>
@@ -6615,6 +7013,13 @@
               </a:solidFill>
             </a:ln>
           </p:spPr>
+          <p:txBody>
+            <a:bodyPr/>
+            <a:lstStyle/>
+            <a:p>
+              <a:endParaRPr lang="en-US"/>
+            </a:p>
+          </p:txBody>
         </p:sp>
         <p:sp>
           <p:nvSpPr>
@@ -6837,9 +7242,18 @@
   <p:clrMapOvr>
     <a:masterClrMapping/>
   </p:clrMapOvr>
-  <p:transition xmlns:p14="http://schemas.microsoft.com/office/powerpoint/2010/main" p14:dur="400">
-    <p:fade/>
-  </p:transition>
+  <mc:AlternateContent xmlns:mc="http://schemas.openxmlformats.org/markup-compatibility/2006">
+    <mc:Choice xmlns:p14="http://schemas.microsoft.com/office/powerpoint/2010/main" Requires="p14">
+      <p:transition p14:dur="400">
+        <p:fade/>
+      </p:transition>
+    </mc:Choice>
+    <mc:Fallback>
+      <p:transition>
+        <p:fade/>
+      </p:transition>
+    </mc:Fallback>
+  </mc:AlternateContent>
 </p:sld>
 </file>
 
@@ -6978,12 +7392,24 @@
         <a:graphic>
           <a:graphicData uri="http://schemas.openxmlformats.org/drawingml/2006/table">
             <a:tbl>
-              <a:tblPr firstRow="1" bandRow="0">
+              <a:tblPr firstRow="1">
                 <a:tableStyleId>{5C22544A-7EE6-4342-B048-85BDC9FD1C3A}</a:tableStyleId>
               </a:tblPr>
               <a:tblGrid>
-                <a:gridCol w="2933700"/>
-                <a:gridCol w="7734300"/>
+                <a:gridCol w="2933700">
+                  <a:extLst>
+                    <a:ext uri="{9D8B030D-6E8A-4147-A177-3AD203B41FA5}">
+                      <a16:colId xmlns:a16="http://schemas.microsoft.com/office/drawing/2014/main" val="20000"/>
+                    </a:ext>
+                  </a:extLst>
+                </a:gridCol>
+                <a:gridCol w="7734300">
+                  <a:extLst>
+                    <a:ext uri="{9D8B030D-6E8A-4147-A177-3AD203B41FA5}">
+                      <a16:colId xmlns:a16="http://schemas.microsoft.com/office/drawing/2014/main" val="20001"/>
+                    </a:ext>
+                  </a:extLst>
+                </a:gridCol>
               </a:tblGrid>
               <a:tr h="555172">
                 <a:tc>
@@ -7084,6 +7510,11 @@
                     </a:solidFill>
                   </a:tcPr>
                 </a:tc>
+                <a:extLst>
+                  <a:ext uri="{0D108BD9-81ED-4DB2-BD59-A6C34878D82A}">
+                    <a16:rowId xmlns:a16="http://schemas.microsoft.com/office/drawing/2014/main" val="10000"/>
+                  </a:ext>
+                </a:extLst>
               </a:tr>
               <a:tr h="555172">
                 <a:tc>
@@ -7091,7 +7522,6 @@
                     <a:bodyPr/>
                     <a:lstStyle/>
                     <a:p>
-                      <a:pPr/>
                       <a:r>
                         <a:rPr lang="en-US" sz="1500" b="0">
                           <a:solidFill>
@@ -7140,7 +7570,6 @@
                     <a:bodyPr/>
                     <a:lstStyle/>
                     <a:p>
-                      <a:pPr/>
                       <a:r>
                         <a:rPr lang="en-US" sz="1500" b="0">
                           <a:solidFill>
@@ -7184,6 +7613,11 @@
                     </a:solidFill>
                   </a:tcPr>
                 </a:tc>
+                <a:extLst>
+                  <a:ext uri="{0D108BD9-81ED-4DB2-BD59-A6C34878D82A}">
+                    <a16:rowId xmlns:a16="http://schemas.microsoft.com/office/drawing/2014/main" val="10001"/>
+                  </a:ext>
+                </a:extLst>
               </a:tr>
               <a:tr h="555172">
                 <a:tc>
@@ -7191,7 +7625,6 @@
                     <a:bodyPr/>
                     <a:lstStyle/>
                     <a:p>
-                      <a:pPr/>
                       <a:r>
                         <a:rPr lang="en-US" sz="1500" b="0">
                           <a:solidFill>
@@ -7240,7 +7673,6 @@
                     <a:bodyPr/>
                     <a:lstStyle/>
                     <a:p>
-                      <a:pPr/>
                       <a:r>
                         <a:rPr lang="en-US" sz="1500" b="0">
                           <a:solidFill>
@@ -7284,6 +7716,11 @@
                     </a:solidFill>
                   </a:tcPr>
                 </a:tc>
+                <a:extLst>
+                  <a:ext uri="{0D108BD9-81ED-4DB2-BD59-A6C34878D82A}">
+                    <a16:rowId xmlns:a16="http://schemas.microsoft.com/office/drawing/2014/main" val="10002"/>
+                  </a:ext>
+                </a:extLst>
               </a:tr>
               <a:tr h="555171">
                 <a:tc>
@@ -7291,7 +7728,6 @@
                     <a:bodyPr/>
                     <a:lstStyle/>
                     <a:p>
-                      <a:pPr/>
                       <a:r>
                         <a:rPr lang="en-US" sz="1500" b="0">
                           <a:solidFill>
@@ -7340,7 +7776,6 @@
                     <a:bodyPr/>
                     <a:lstStyle/>
                     <a:p>
-                      <a:pPr/>
                       <a:r>
                         <a:rPr lang="en-US" sz="1500" b="0">
                           <a:solidFill>
@@ -7384,6 +7819,11 @@
                     </a:solidFill>
                   </a:tcPr>
                 </a:tc>
+                <a:extLst>
+                  <a:ext uri="{0D108BD9-81ED-4DB2-BD59-A6C34878D82A}">
+                    <a16:rowId xmlns:a16="http://schemas.microsoft.com/office/drawing/2014/main" val="10003"/>
+                  </a:ext>
+                </a:extLst>
               </a:tr>
               <a:tr h="555171">
                 <a:tc>
@@ -7391,7 +7831,6 @@
                     <a:bodyPr/>
                     <a:lstStyle/>
                     <a:p>
-                      <a:pPr/>
                       <a:r>
                         <a:rPr lang="en-US" sz="1500" b="0">
                           <a:solidFill>
@@ -7440,7 +7879,6 @@
                     <a:bodyPr/>
                     <a:lstStyle/>
                     <a:p>
-                      <a:pPr/>
                       <a:r>
                         <a:rPr lang="en-US" sz="1500" b="0">
                           <a:solidFill>
@@ -7484,6 +7922,11 @@
                     </a:solidFill>
                   </a:tcPr>
                 </a:tc>
+                <a:extLst>
+                  <a:ext uri="{0D108BD9-81ED-4DB2-BD59-A6C34878D82A}">
+                    <a16:rowId xmlns:a16="http://schemas.microsoft.com/office/drawing/2014/main" val="10004"/>
+                  </a:ext>
+                </a:extLst>
               </a:tr>
               <a:tr h="555171">
                 <a:tc>
@@ -7491,7 +7934,6 @@
                     <a:bodyPr/>
                     <a:lstStyle/>
                     <a:p>
-                      <a:pPr/>
                       <a:r>
                         <a:rPr lang="en-US" sz="1500" b="0">
                           <a:solidFill>
@@ -7540,7 +7982,6 @@
                     <a:bodyPr/>
                     <a:lstStyle/>
                     <a:p>
-                      <a:pPr/>
                       <a:r>
                         <a:rPr lang="en-US" sz="1500" b="0">
                           <a:solidFill>
@@ -7584,6 +8025,11 @@
                     </a:solidFill>
                   </a:tcPr>
                 </a:tc>
+                <a:extLst>
+                  <a:ext uri="{0D108BD9-81ED-4DB2-BD59-A6C34878D82A}">
+                    <a16:rowId xmlns:a16="http://schemas.microsoft.com/office/drawing/2014/main" val="10005"/>
+                  </a:ext>
+                </a:extLst>
               </a:tr>
               <a:tr h="555171">
                 <a:tc>
@@ -7591,7 +8037,6 @@
                     <a:bodyPr/>
                     <a:lstStyle/>
                     <a:p>
-                      <a:pPr/>
                       <a:r>
                         <a:rPr lang="en-US" sz="1500" b="0">
                           <a:solidFill>
@@ -7640,7 +8085,6 @@
                     <a:bodyPr/>
                     <a:lstStyle/>
                     <a:p>
-                      <a:pPr/>
                       <a:r>
                         <a:rPr lang="en-US" sz="1500" b="0">
                           <a:solidFill>
@@ -7684,6 +8128,11 @@
                     </a:solidFill>
                   </a:tcPr>
                 </a:tc>
+                <a:extLst>
+                  <a:ext uri="{0D108BD9-81ED-4DB2-BD59-A6C34878D82A}">
+                    <a16:rowId xmlns:a16="http://schemas.microsoft.com/office/drawing/2014/main" val="10006"/>
+                  </a:ext>
+                </a:extLst>
               </a:tr>
             </a:tbl>
           </a:graphicData>
@@ -7789,9 +8238,18 @@
   <p:clrMapOvr>
     <a:masterClrMapping/>
   </p:clrMapOvr>
-  <p:transition xmlns:p14="http://schemas.microsoft.com/office/powerpoint/2010/main" p14:dur="400">
-    <p:fade/>
-  </p:transition>
+  <mc:AlternateContent xmlns:mc="http://schemas.openxmlformats.org/markup-compatibility/2006">
+    <mc:Choice xmlns:p14="http://schemas.microsoft.com/office/powerpoint/2010/main" Requires="p14">
+      <p:transition p14:dur="400">
+        <p:fade/>
+      </p:transition>
+    </mc:Choice>
+    <mc:Fallback>
+      <p:transition>
+        <p:fade/>
+      </p:transition>
+    </mc:Fallback>
+  </mc:AlternateContent>
 </p:sld>
 </file>
 
@@ -7981,6 +8439,13 @@
               <a:tailEnd type="triangle" w="lg" len="lg"/>
             </a:ln>
           </p:spPr>
+          <p:txBody>
+            <a:bodyPr/>
+            <a:lstStyle/>
+            <a:p>
+              <a:endParaRPr lang="en-US"/>
+            </a:p>
+          </p:txBody>
         </p:sp>
         <p:grpSp>
           <p:nvGrpSpPr>
@@ -8021,6 +8486,13 @@
                 </a:solidFill>
               </a:ln>
             </p:spPr>
+            <p:txBody>
+              <a:bodyPr/>
+              <a:lstStyle/>
+              <a:p>
+                <a:endParaRPr lang="en-US"/>
+              </a:p>
+            </p:txBody>
           </p:sp>
           <p:sp>
             <p:nvSpPr>
@@ -8047,6 +8519,13 @@
                 </a:solidFill>
               </a:ln>
             </p:spPr>
+            <p:txBody>
+              <a:bodyPr/>
+              <a:lstStyle/>
+              <a:p>
+                <a:endParaRPr lang="en-US"/>
+              </a:p>
+            </p:txBody>
           </p:sp>
           <p:sp>
             <p:nvSpPr>
@@ -8073,6 +8552,13 @@
                 </a:solidFill>
               </a:ln>
             </p:spPr>
+            <p:txBody>
+              <a:bodyPr/>
+              <a:lstStyle/>
+              <a:p>
+                <a:endParaRPr lang="en-US"/>
+              </a:p>
+            </p:txBody>
           </p:sp>
           <p:sp>
             <p:nvSpPr>
@@ -8099,6 +8585,13 @@
                 </a:solidFill>
               </a:ln>
             </p:spPr>
+            <p:txBody>
+              <a:bodyPr/>
+              <a:lstStyle/>
+              <a:p>
+                <a:endParaRPr lang="en-US"/>
+              </a:p>
+            </p:txBody>
           </p:sp>
           <p:sp>
             <p:nvSpPr>
@@ -8125,6 +8618,13 @@
                 </a:solidFill>
               </a:ln>
             </p:spPr>
+            <p:txBody>
+              <a:bodyPr/>
+              <a:lstStyle/>
+              <a:p>
+                <a:endParaRPr lang="en-US"/>
+              </a:p>
+            </p:txBody>
           </p:sp>
           <p:sp>
             <p:nvSpPr>
@@ -8151,6 +8651,13 @@
                 </a:solidFill>
               </a:ln>
             </p:spPr>
+            <p:txBody>
+              <a:bodyPr/>
+              <a:lstStyle/>
+              <a:p>
+                <a:endParaRPr lang="en-US"/>
+              </a:p>
+            </p:txBody>
           </p:sp>
         </p:grpSp>
         <p:grpSp>
@@ -8789,9 +9296,18 @@
   <p:clrMapOvr>
     <a:masterClrMapping/>
   </p:clrMapOvr>
-  <p:transition xmlns:p14="http://schemas.microsoft.com/office/powerpoint/2010/main" p14:dur="400">
-    <p:fade/>
-  </p:transition>
+  <mc:AlternateContent xmlns:mc="http://schemas.openxmlformats.org/markup-compatibility/2006">
+    <mc:Choice xmlns:p14="http://schemas.microsoft.com/office/powerpoint/2010/main" Requires="p14">
+      <p:transition p14:dur="400">
+        <p:fade/>
+      </p:transition>
+    </mc:Choice>
+    <mc:Fallback>
+      <p:transition>
+        <p:fade/>
+      </p:transition>
+    </mc:Fallback>
+  </mc:AlternateContent>
 </p:sld>
 </file>
 
@@ -8939,7 +9455,7 @@
         </p:nvGrpSpPr>
         <p:grpSpPr>
           <a:xfrm>
-            <a:off x="1619250" y="1619250"/>
+            <a:off x="1619250" y="1765300"/>
             <a:ext cx="8096250" cy="4133850"/>
             <a:chOff x="1619250" y="1619250"/>
             <a:chExt cx="8096250" cy="4133850"/>
@@ -8968,6 +9484,13 @@
               </a:solidFill>
             </a:ln>
           </p:spPr>
+          <p:txBody>
+            <a:bodyPr/>
+            <a:lstStyle/>
+            <a:p>
+              <a:endParaRPr lang="en-US"/>
+            </a:p>
+          </p:txBody>
         </p:sp>
         <p:sp>
           <p:nvSpPr>
@@ -9088,6 +9611,13 @@
                 </a:solidFill>
               </a:ln>
             </p:spPr>
+            <p:txBody>
+              <a:bodyPr/>
+              <a:lstStyle/>
+              <a:p>
+                <a:endParaRPr lang="en-US"/>
+              </a:p>
+            </p:txBody>
           </p:sp>
           <p:sp>
             <p:nvSpPr>
@@ -9114,6 +9644,13 @@
                 </a:solidFill>
               </a:ln>
             </p:spPr>
+            <p:txBody>
+              <a:bodyPr/>
+              <a:lstStyle/>
+              <a:p>
+                <a:endParaRPr lang="en-US"/>
+              </a:p>
+            </p:txBody>
           </p:sp>
           <p:sp>
             <p:nvSpPr>
@@ -9140,6 +9677,13 @@
                 </a:solidFill>
               </a:ln>
             </p:spPr>
+            <p:txBody>
+              <a:bodyPr/>
+              <a:lstStyle/>
+              <a:p>
+                <a:endParaRPr lang="en-US"/>
+              </a:p>
+            </p:txBody>
           </p:sp>
           <p:sp>
             <p:nvSpPr>
@@ -9166,6 +9710,13 @@
                 </a:solidFill>
               </a:ln>
             </p:spPr>
+            <p:txBody>
+              <a:bodyPr/>
+              <a:lstStyle/>
+              <a:p>
+                <a:endParaRPr lang="en-US"/>
+              </a:p>
+            </p:txBody>
           </p:sp>
           <p:sp>
             <p:nvSpPr>
@@ -9192,6 +9743,13 @@
                 </a:solidFill>
               </a:ln>
             </p:spPr>
+            <p:txBody>
+              <a:bodyPr/>
+              <a:lstStyle/>
+              <a:p>
+                <a:endParaRPr lang="en-US"/>
+              </a:p>
+            </p:txBody>
           </p:sp>
         </p:grpSp>
         <p:grpSp>
@@ -9710,9 +10268,18 @@
   <p:clrMapOvr>
     <a:masterClrMapping/>
   </p:clrMapOvr>
-  <p:transition xmlns:p14="http://schemas.microsoft.com/office/powerpoint/2010/main" p14:dur="400">
-    <p:fade/>
-  </p:transition>
+  <mc:AlternateContent xmlns:mc="http://schemas.openxmlformats.org/markup-compatibility/2006">
+    <mc:Choice xmlns:p14="http://schemas.microsoft.com/office/powerpoint/2010/main" Requires="p14">
+      <p:transition p14:dur="400">
+        <p:fade/>
+      </p:transition>
+    </mc:Choice>
+    <mc:Fallback>
+      <p:transition>
+        <p:fade/>
+      </p:transition>
+    </mc:Fallback>
+  </mc:AlternateContent>
 </p:sld>
 </file>
 
@@ -9844,7 +10411,7 @@
         </p:nvGrpSpPr>
         <p:grpSpPr>
           <a:xfrm>
-            <a:off x="3695700" y="1143000"/>
+            <a:off x="3695700" y="1479550"/>
             <a:ext cx="4820283" cy="5334000"/>
             <a:chOff x="3695700" y="1143000"/>
             <a:chExt cx="4820283" cy="5334000"/>
@@ -9874,6 +10441,13 @@
               </a:custDash>
             </a:ln>
           </p:spPr>
+          <p:txBody>
+            <a:bodyPr/>
+            <a:lstStyle/>
+            <a:p>
+              <a:endParaRPr lang="en-US"/>
+            </a:p>
+          </p:txBody>
         </p:sp>
         <p:sp>
           <p:nvSpPr>
@@ -9913,6 +10487,13 @@
               <a:tailEnd type="triangle" w="lg" len="lg"/>
             </a:ln>
           </p:spPr>
+          <p:txBody>
+            <a:bodyPr/>
+            <a:lstStyle/>
+            <a:p>
+              <a:endParaRPr lang="en-US"/>
+            </a:p>
+          </p:txBody>
         </p:sp>
         <p:sp>
           <p:nvSpPr>
@@ -9937,6 +10518,13 @@
               </a:solidFill>
             </a:ln>
           </p:spPr>
+          <p:txBody>
+            <a:bodyPr/>
+            <a:lstStyle/>
+            <a:p>
+              <a:endParaRPr lang="en-US"/>
+            </a:p>
+          </p:txBody>
         </p:sp>
         <p:sp>
           <p:nvSpPr>
@@ -10055,6 +10643,13 @@
                 </a:solidFill>
               </a:ln>
             </p:spPr>
+            <p:txBody>
+              <a:bodyPr/>
+              <a:lstStyle/>
+              <a:p>
+                <a:endParaRPr lang="en-US"/>
+              </a:p>
+            </p:txBody>
           </p:sp>
           <p:sp>
             <p:nvSpPr>
@@ -10079,6 +10674,13 @@
                 </a:solidFill>
               </a:ln>
             </p:spPr>
+            <p:txBody>
+              <a:bodyPr/>
+              <a:lstStyle/>
+              <a:p>
+                <a:endParaRPr lang="en-US"/>
+              </a:p>
+            </p:txBody>
           </p:sp>
           <p:sp>
             <p:nvSpPr>
@@ -10103,6 +10705,13 @@
                 </a:solidFill>
               </a:ln>
             </p:spPr>
+            <p:txBody>
+              <a:bodyPr/>
+              <a:lstStyle/>
+              <a:p>
+                <a:endParaRPr lang="en-US"/>
+              </a:p>
+            </p:txBody>
           </p:sp>
           <p:sp>
             <p:nvSpPr>
@@ -10127,6 +10736,13 @@
                 </a:solidFill>
               </a:ln>
             </p:spPr>
+            <p:txBody>
+              <a:bodyPr/>
+              <a:lstStyle/>
+              <a:p>
+                <a:endParaRPr lang="en-US"/>
+              </a:p>
+            </p:txBody>
           </p:sp>
           <p:sp>
             <p:nvSpPr>
@@ -10151,6 +10767,13 @@
                 </a:solidFill>
               </a:ln>
             </p:spPr>
+            <p:txBody>
+              <a:bodyPr/>
+              <a:lstStyle/>
+              <a:p>
+                <a:endParaRPr lang="en-US"/>
+              </a:p>
+            </p:txBody>
           </p:sp>
           <p:sp>
             <p:nvSpPr>
@@ -10175,6 +10798,13 @@
                 </a:solidFill>
               </a:ln>
             </p:spPr>
+            <p:txBody>
+              <a:bodyPr/>
+              <a:lstStyle/>
+              <a:p>
+                <a:endParaRPr lang="en-US"/>
+              </a:p>
+            </p:txBody>
           </p:sp>
         </p:grpSp>
         <p:grpSp>
@@ -10533,9 +11163,18 @@
   <p:clrMapOvr>
     <a:masterClrMapping/>
   </p:clrMapOvr>
-  <p:transition xmlns:p14="http://schemas.microsoft.com/office/powerpoint/2010/main" p14:dur="400">
-    <p:fade/>
-  </p:transition>
+  <mc:AlternateContent xmlns:mc="http://schemas.openxmlformats.org/markup-compatibility/2006">
+    <mc:Choice xmlns:p14="http://schemas.microsoft.com/office/powerpoint/2010/main" Requires="p14">
+      <p:transition p14:dur="400">
+        <p:fade/>
+      </p:transition>
+    </mc:Choice>
+    <mc:Fallback>
+      <p:transition>
+        <p:fade/>
+      </p:transition>
+    </mc:Fallback>
+  </mc:AlternateContent>
 </p:sld>
 </file>
 
@@ -10752,6 +11391,13 @@
                 </a:solidFill>
               </a:ln>
             </p:spPr>
+            <p:txBody>
+              <a:bodyPr/>
+              <a:lstStyle/>
+              <a:p>
+                <a:endParaRPr lang="en-US"/>
+              </a:p>
+            </p:txBody>
           </p:sp>
           <p:sp>
             <p:nvSpPr>
@@ -10778,6 +11424,13 @@
                 </a:solidFill>
               </a:ln>
             </p:spPr>
+            <p:txBody>
+              <a:bodyPr/>
+              <a:lstStyle/>
+              <a:p>
+                <a:endParaRPr lang="en-US"/>
+              </a:p>
+            </p:txBody>
           </p:sp>
           <p:sp>
             <p:nvSpPr>
@@ -10804,6 +11457,13 @@
                 </a:solidFill>
               </a:ln>
             </p:spPr>
+            <p:txBody>
+              <a:bodyPr/>
+              <a:lstStyle/>
+              <a:p>
+                <a:endParaRPr lang="en-US"/>
+              </a:p>
+            </p:txBody>
           </p:sp>
           <p:sp>
             <p:nvSpPr>
@@ -10830,6 +11490,13 @@
                 </a:solidFill>
               </a:ln>
             </p:spPr>
+            <p:txBody>
+              <a:bodyPr/>
+              <a:lstStyle/>
+              <a:p>
+                <a:endParaRPr lang="en-US"/>
+              </a:p>
+            </p:txBody>
           </p:sp>
           <p:sp>
             <p:nvSpPr>
@@ -10856,6 +11523,13 @@
                 </a:solidFill>
               </a:ln>
             </p:spPr>
+            <p:txBody>
+              <a:bodyPr/>
+              <a:lstStyle/>
+              <a:p>
+                <a:endParaRPr lang="en-US"/>
+              </a:p>
+            </p:txBody>
           </p:sp>
           <p:sp>
             <p:nvSpPr>
@@ -10882,6 +11556,13 @@
                 </a:solidFill>
               </a:ln>
             </p:spPr>
+            <p:txBody>
+              <a:bodyPr/>
+              <a:lstStyle/>
+              <a:p>
+                <a:endParaRPr lang="en-US"/>
+              </a:p>
+            </p:txBody>
           </p:sp>
         </p:grpSp>
         <p:grpSp>
@@ -11401,6 +12082,13 @@
               <a:tailEnd type="triangle" w="lg" len="lg"/>
             </a:ln>
           </p:spPr>
+          <p:txBody>
+            <a:bodyPr/>
+            <a:lstStyle/>
+            <a:p>
+              <a:endParaRPr lang="en-US"/>
+            </a:p>
+          </p:txBody>
         </p:sp>
         <p:sp>
           <p:nvSpPr>
@@ -11424,6 +12112,13 @@
               <a:tailEnd type="triangle" w="lg" len="lg"/>
             </a:ln>
           </p:spPr>
+          <p:txBody>
+            <a:bodyPr/>
+            <a:lstStyle/>
+            <a:p>
+              <a:endParaRPr lang="en-US"/>
+            </a:p>
+          </p:txBody>
         </p:sp>
         <p:sp>
           <p:nvSpPr>
@@ -11447,6 +12142,13 @@
               <a:tailEnd type="triangle" w="lg" len="lg"/>
             </a:ln>
           </p:spPr>
+          <p:txBody>
+            <a:bodyPr/>
+            <a:lstStyle/>
+            <a:p>
+              <a:endParaRPr lang="en-US"/>
+            </a:p>
+          </p:txBody>
         </p:sp>
         <p:sp>
           <p:nvSpPr>
@@ -11470,6 +12172,13 @@
               <a:tailEnd type="triangle" w="lg" len="lg"/>
             </a:ln>
           </p:spPr>
+          <p:txBody>
+            <a:bodyPr/>
+            <a:lstStyle/>
+            <a:p>
+              <a:endParaRPr lang="en-US"/>
+            </a:p>
+          </p:txBody>
         </p:sp>
         <p:sp>
           <p:nvSpPr>
@@ -11493,6 +12202,13 @@
               <a:tailEnd type="triangle" w="lg" len="lg"/>
             </a:ln>
           </p:spPr>
+          <p:txBody>
+            <a:bodyPr/>
+            <a:lstStyle/>
+            <a:p>
+              <a:endParaRPr lang="en-US"/>
+            </a:p>
+          </p:txBody>
         </p:sp>
         <p:sp>
           <p:nvSpPr>
@@ -11516,6 +12232,13 @@
               <a:tailEnd type="triangle" w="lg" len="lg"/>
             </a:ln>
           </p:spPr>
+          <p:txBody>
+            <a:bodyPr/>
+            <a:lstStyle/>
+            <a:p>
+              <a:endParaRPr lang="en-US"/>
+            </a:p>
+          </p:txBody>
         </p:sp>
         <p:sp>
           <p:nvSpPr>
@@ -11558,6 +12281,13 @@
               <a:tailEnd type="triangle" w="lg" len="lg"/>
             </a:ln>
           </p:spPr>
+          <p:txBody>
+            <a:bodyPr/>
+            <a:lstStyle/>
+            <a:p>
+              <a:endParaRPr lang="en-US"/>
+            </a:p>
+          </p:txBody>
         </p:sp>
         <p:sp>
           <p:nvSpPr>
@@ -11580,6 +12310,13 @@
               <a:noFill/>
             </a:ln>
           </p:spPr>
+          <p:txBody>
+            <a:bodyPr/>
+            <a:lstStyle/>
+            <a:p>
+              <a:endParaRPr lang="en-US"/>
+            </a:p>
+          </p:txBody>
         </p:sp>
         <p:sp>
           <p:nvSpPr>
@@ -11722,9 +12459,18 @@
   <p:clrMapOvr>
     <a:masterClrMapping/>
   </p:clrMapOvr>
-  <p:transition xmlns:p14="http://schemas.microsoft.com/office/powerpoint/2010/main" p14:dur="400">
-    <p:fade/>
-  </p:transition>
+  <mc:AlternateContent xmlns:mc="http://schemas.openxmlformats.org/markup-compatibility/2006">
+    <mc:Choice xmlns:p14="http://schemas.microsoft.com/office/powerpoint/2010/main" Requires="p14">
+      <p:transition p14:dur="400">
+        <p:fade/>
+      </p:transition>
+    </mc:Choice>
+    <mc:Fallback>
+      <p:transition>
+        <p:fade/>
+      </p:transition>
+    </mc:Fallback>
+  </mc:AlternateContent>
 </p:sld>
 </file>
 
@@ -11913,6 +12659,13 @@
               </a:solidFill>
             </a:ln>
           </p:spPr>
+          <p:txBody>
+            <a:bodyPr/>
+            <a:lstStyle/>
+            <a:p>
+              <a:endParaRPr lang="en-US"/>
+            </a:p>
+          </p:txBody>
         </p:sp>
         <p:grpSp>
           <p:nvGrpSpPr>
@@ -11953,6 +12706,13 @@
                 </a:solidFill>
               </a:ln>
             </p:spPr>
+            <p:txBody>
+              <a:bodyPr/>
+              <a:lstStyle/>
+              <a:p>
+                <a:endParaRPr lang="en-US"/>
+              </a:p>
+            </p:txBody>
           </p:sp>
           <p:sp>
             <p:nvSpPr>
@@ -11979,6 +12739,13 @@
                 </a:solidFill>
               </a:ln>
             </p:spPr>
+            <p:txBody>
+              <a:bodyPr/>
+              <a:lstStyle/>
+              <a:p>
+                <a:endParaRPr lang="en-US"/>
+              </a:p>
+            </p:txBody>
           </p:sp>
           <p:sp>
             <p:nvSpPr>
@@ -12005,6 +12772,13 @@
                 </a:solidFill>
               </a:ln>
             </p:spPr>
+            <p:txBody>
+              <a:bodyPr/>
+              <a:lstStyle/>
+              <a:p>
+                <a:endParaRPr lang="en-US"/>
+              </a:p>
+            </p:txBody>
           </p:sp>
         </p:grpSp>
         <p:grpSp>
@@ -12042,6 +12816,13 @@
                 <a:noFill/>
               </a:ln>
             </p:spPr>
+            <p:txBody>
+              <a:bodyPr/>
+              <a:lstStyle/>
+              <a:p>
+                <a:endParaRPr lang="en-US"/>
+              </a:p>
+            </p:txBody>
           </p:sp>
           <p:sp>
             <p:nvSpPr>
@@ -12064,6 +12845,13 @@
                 <a:noFill/>
               </a:ln>
             </p:spPr>
+            <p:txBody>
+              <a:bodyPr/>
+              <a:lstStyle/>
+              <a:p>
+                <a:endParaRPr lang="en-US"/>
+              </a:p>
+            </p:txBody>
           </p:sp>
           <p:sp>
             <p:nvSpPr>
@@ -12086,6 +12874,13 @@
                 <a:noFill/>
               </a:ln>
             </p:spPr>
+            <p:txBody>
+              <a:bodyPr/>
+              <a:lstStyle/>
+              <a:p>
+                <a:endParaRPr lang="en-US"/>
+              </a:p>
+            </p:txBody>
           </p:sp>
         </p:grpSp>
         <p:grpSp>
@@ -12366,6 +13161,13 @@
               </a:solidFill>
             </a:ln>
           </p:spPr>
+          <p:txBody>
+            <a:bodyPr/>
+            <a:lstStyle/>
+            <a:p>
+              <a:endParaRPr lang="en-US"/>
+            </a:p>
+          </p:txBody>
         </p:sp>
         <p:sp>
           <p:nvSpPr>
@@ -12563,9 +13365,18 @@
   <p:clrMapOvr>
     <a:masterClrMapping/>
   </p:clrMapOvr>
-  <p:transition xmlns:p14="http://schemas.microsoft.com/office/powerpoint/2010/main" p14:dur="400">
-    <p:fade/>
-  </p:transition>
+  <mc:AlternateContent xmlns:mc="http://schemas.openxmlformats.org/markup-compatibility/2006">
+    <mc:Choice xmlns:p14="http://schemas.microsoft.com/office/powerpoint/2010/main" Requires="p14">
+      <p:transition p14:dur="400">
+        <p:fade/>
+      </p:transition>
+    </mc:Choice>
+    <mc:Fallback>
+      <p:transition>
+        <p:fade/>
+      </p:transition>
+    </mc:Fallback>
+  </mc:AlternateContent>
 </p:sld>
 </file>
 
@@ -12725,6 +13536,13 @@
               <a:tailEnd type="triangle" w="lg" len="lg"/>
             </a:ln>
           </p:spPr>
+          <p:txBody>
+            <a:bodyPr/>
+            <a:lstStyle/>
+            <a:p>
+              <a:endParaRPr lang="en-US"/>
+            </a:p>
+          </p:txBody>
         </p:sp>
         <p:sp>
           <p:nvSpPr>
@@ -12805,6 +13623,13 @@
                 </a:solidFill>
               </a:ln>
             </p:spPr>
+            <p:txBody>
+              <a:bodyPr/>
+              <a:lstStyle/>
+              <a:p>
+                <a:endParaRPr lang="en-US"/>
+              </a:p>
+            </p:txBody>
           </p:sp>
           <p:sp>
             <p:nvSpPr>
@@ -12966,6 +13791,13 @@
                 </a:solidFill>
               </a:ln>
             </p:spPr>
+            <p:txBody>
+              <a:bodyPr/>
+              <a:lstStyle/>
+              <a:p>
+                <a:endParaRPr lang="en-US"/>
+              </a:p>
+            </p:txBody>
           </p:sp>
           <p:sp>
             <p:nvSpPr>
@@ -13127,6 +13959,13 @@
                 </a:solidFill>
               </a:ln>
             </p:spPr>
+            <p:txBody>
+              <a:bodyPr/>
+              <a:lstStyle/>
+              <a:p>
+                <a:endParaRPr lang="en-US"/>
+              </a:p>
+            </p:txBody>
           </p:sp>
           <p:sp>
             <p:nvSpPr>
@@ -13350,9 +14189,18 @@
   <p:clrMapOvr>
     <a:masterClrMapping/>
   </p:clrMapOvr>
-  <p:transition xmlns:p14="http://schemas.microsoft.com/office/powerpoint/2010/main" p14:dur="400">
-    <p:fade/>
-  </p:transition>
+  <mc:AlternateContent xmlns:mc="http://schemas.openxmlformats.org/markup-compatibility/2006">
+    <mc:Choice xmlns:p14="http://schemas.microsoft.com/office/powerpoint/2010/main" Requires="p14">
+      <p:transition p14:dur="400">
+        <p:fade/>
+      </p:transition>
+    </mc:Choice>
+    <mc:Fallback>
+      <p:transition>
+        <p:fade/>
+      </p:transition>
+    </mc:Fallback>
+  </mc:AlternateContent>
 </p:sld>
 </file>
 
@@ -13512,6 +14360,13 @@
               <a:tailEnd type="triangle" w="lg" len="lg"/>
             </a:ln>
           </p:spPr>
+          <p:txBody>
+            <a:bodyPr/>
+            <a:lstStyle/>
+            <a:p>
+              <a:endParaRPr lang="en-US"/>
+            </a:p>
+          </p:txBody>
         </p:sp>
         <p:grpSp>
           <p:nvGrpSpPr>
@@ -13552,6 +14407,13 @@
                 </a:solidFill>
               </a:ln>
             </p:spPr>
+            <p:txBody>
+              <a:bodyPr/>
+              <a:lstStyle/>
+              <a:p>
+                <a:endParaRPr lang="en-US"/>
+              </a:p>
+            </p:txBody>
           </p:sp>
           <p:sp>
             <p:nvSpPr>
@@ -13578,6 +14440,13 @@
                 </a:solidFill>
               </a:ln>
             </p:spPr>
+            <p:txBody>
+              <a:bodyPr/>
+              <a:lstStyle/>
+              <a:p>
+                <a:endParaRPr lang="en-US"/>
+              </a:p>
+            </p:txBody>
           </p:sp>
           <p:sp>
             <p:nvSpPr>
@@ -13604,6 +14473,13 @@
                 </a:solidFill>
               </a:ln>
             </p:spPr>
+            <p:txBody>
+              <a:bodyPr/>
+              <a:lstStyle/>
+              <a:p>
+                <a:endParaRPr lang="en-US"/>
+              </a:p>
+            </p:txBody>
           </p:sp>
           <p:sp>
             <p:nvSpPr>
@@ -13630,6 +14506,13 @@
                 </a:solidFill>
               </a:ln>
             </p:spPr>
+            <p:txBody>
+              <a:bodyPr/>
+              <a:lstStyle/>
+              <a:p>
+                <a:endParaRPr lang="en-US"/>
+              </a:p>
+            </p:txBody>
           </p:sp>
           <p:sp>
             <p:nvSpPr>
@@ -13656,6 +14539,13 @@
                 </a:solidFill>
               </a:ln>
             </p:spPr>
+            <p:txBody>
+              <a:bodyPr/>
+              <a:lstStyle/>
+              <a:p>
+                <a:endParaRPr lang="en-US"/>
+              </a:p>
+            </p:txBody>
           </p:sp>
         </p:grpSp>
         <p:grpSp>
@@ -14113,6 +15003,13 @@
               </a:solidFill>
             </a:ln>
           </p:spPr>
+          <p:txBody>
+            <a:bodyPr/>
+            <a:lstStyle/>
+            <a:p>
+              <a:endParaRPr lang="en-US"/>
+            </a:p>
+          </p:txBody>
         </p:sp>
         <p:sp>
           <p:nvSpPr>
@@ -14255,9 +15152,18 @@
   <p:clrMapOvr>
     <a:masterClrMapping/>
   </p:clrMapOvr>
-  <p:transition xmlns:p14="http://schemas.microsoft.com/office/powerpoint/2010/main" p14:dur="400">
-    <p:fade/>
-  </p:transition>
+  <mc:AlternateContent xmlns:mc="http://schemas.openxmlformats.org/markup-compatibility/2006">
+    <mc:Choice xmlns:p14="http://schemas.microsoft.com/office/powerpoint/2010/main" Requires="p14">
+      <p:transition p14:dur="400">
+        <p:fade/>
+      </p:transition>
+    </mc:Choice>
+    <mc:Fallback>
+      <p:transition>
+        <p:fade/>
+      </p:transition>
+    </mc:Fallback>
+  </mc:AlternateContent>
 </p:sld>
 </file>
 
@@ -14433,6 +15339,13 @@
               <a:tailEnd type="triangle" w="lg" len="lg"/>
             </a:ln>
           </p:spPr>
+          <p:txBody>
+            <a:bodyPr/>
+            <a:lstStyle/>
+            <a:p>
+              <a:endParaRPr lang="en-US"/>
+            </a:p>
+          </p:txBody>
         </p:sp>
         <p:sp>
           <p:nvSpPr>
@@ -14472,6 +15385,13 @@
               <a:tailEnd type="triangle" w="lg" len="lg"/>
             </a:ln>
           </p:spPr>
+          <p:txBody>
+            <a:bodyPr/>
+            <a:lstStyle/>
+            <a:p>
+              <a:endParaRPr lang="en-US"/>
+            </a:p>
+          </p:txBody>
         </p:sp>
         <p:sp>
           <p:nvSpPr>
@@ -14514,6 +15434,13 @@
               <a:tailEnd type="triangle" w="lg" len="lg"/>
             </a:ln>
           </p:spPr>
+          <p:txBody>
+            <a:bodyPr/>
+            <a:lstStyle/>
+            <a:p>
+              <a:endParaRPr lang="en-US"/>
+            </a:p>
+          </p:txBody>
         </p:sp>
         <p:sp>
           <p:nvSpPr>
@@ -14556,6 +15483,13 @@
               <a:tailEnd type="triangle" w="lg" len="lg"/>
             </a:ln>
           </p:spPr>
+          <p:txBody>
+            <a:bodyPr/>
+            <a:lstStyle/>
+            <a:p>
+              <a:endParaRPr lang="en-US"/>
+            </a:p>
+          </p:txBody>
         </p:sp>
         <p:grpSp>
           <p:nvGrpSpPr>
@@ -14596,6 +15530,13 @@
                 </a:solidFill>
               </a:ln>
             </p:spPr>
+            <p:txBody>
+              <a:bodyPr/>
+              <a:lstStyle/>
+              <a:p>
+                <a:endParaRPr lang="en-US"/>
+              </a:p>
+            </p:txBody>
           </p:sp>
           <p:sp>
             <p:nvSpPr>
@@ -14622,6 +15563,13 @@
                 </a:solidFill>
               </a:ln>
             </p:spPr>
+            <p:txBody>
+              <a:bodyPr/>
+              <a:lstStyle/>
+              <a:p>
+                <a:endParaRPr lang="en-US"/>
+              </a:p>
+            </p:txBody>
           </p:sp>
           <p:sp>
             <p:nvSpPr>
@@ -14648,6 +15596,13 @@
                 </a:solidFill>
               </a:ln>
             </p:spPr>
+            <p:txBody>
+              <a:bodyPr/>
+              <a:lstStyle/>
+              <a:p>
+                <a:endParaRPr lang="en-US"/>
+              </a:p>
+            </p:txBody>
           </p:sp>
           <p:sp>
             <p:nvSpPr>
@@ -14674,6 +15629,13 @@
                 </a:solidFill>
               </a:ln>
             </p:spPr>
+            <p:txBody>
+              <a:bodyPr/>
+              <a:lstStyle/>
+              <a:p>
+                <a:endParaRPr lang="en-US"/>
+              </a:p>
+            </p:txBody>
           </p:sp>
           <p:sp>
             <p:nvSpPr>
@@ -14700,6 +15662,13 @@
                 </a:solidFill>
               </a:ln>
             </p:spPr>
+            <p:txBody>
+              <a:bodyPr/>
+              <a:lstStyle/>
+              <a:p>
+                <a:endParaRPr lang="en-US"/>
+              </a:p>
+            </p:txBody>
           </p:sp>
         </p:grpSp>
         <p:grpSp>
@@ -15058,9 +16027,18 @@
   <p:clrMapOvr>
     <a:masterClrMapping/>
   </p:clrMapOvr>
-  <p:transition xmlns:p14="http://schemas.microsoft.com/office/powerpoint/2010/main" p14:dur="400">
-    <p:fade/>
-  </p:transition>
+  <mc:AlternateContent xmlns:mc="http://schemas.openxmlformats.org/markup-compatibility/2006">
+    <mc:Choice xmlns:p14="http://schemas.microsoft.com/office/powerpoint/2010/main" Requires="p14">
+      <p:transition p14:dur="400">
+        <p:fade/>
+      </p:transition>
+    </mc:Choice>
+    <mc:Fallback>
+      <p:transition>
+        <p:fade/>
+      </p:transition>
+    </mc:Fallback>
+  </mc:AlternateContent>
 </p:sld>
 </file>
 
@@ -15282,6 +16260,13 @@
               </a:solidFill>
             </a:ln>
           </p:spPr>
+          <p:txBody>
+            <a:bodyPr/>
+            <a:lstStyle/>
+            <a:p>
+              <a:endParaRPr lang="en-US"/>
+            </a:p>
+          </p:txBody>
         </p:sp>
         <p:sp>
           <p:nvSpPr>
@@ -15402,6 +16387,13 @@
                 </a:solidFill>
               </a:ln>
             </p:spPr>
+            <p:txBody>
+              <a:bodyPr/>
+              <a:lstStyle/>
+              <a:p>
+                <a:endParaRPr lang="en-US"/>
+              </a:p>
+            </p:txBody>
           </p:sp>
           <p:sp>
             <p:nvSpPr>
@@ -15428,6 +16420,13 @@
                 </a:solidFill>
               </a:ln>
             </p:spPr>
+            <p:txBody>
+              <a:bodyPr/>
+              <a:lstStyle/>
+              <a:p>
+                <a:endParaRPr lang="en-US"/>
+              </a:p>
+            </p:txBody>
           </p:sp>
           <p:sp>
             <p:nvSpPr>
@@ -15454,6 +16453,13 @@
                 </a:solidFill>
               </a:ln>
             </p:spPr>
+            <p:txBody>
+              <a:bodyPr/>
+              <a:lstStyle/>
+              <a:p>
+                <a:endParaRPr lang="en-US"/>
+              </a:p>
+            </p:txBody>
           </p:sp>
           <p:sp>
             <p:nvSpPr>
@@ -15480,6 +16486,13 @@
                 </a:solidFill>
               </a:ln>
             </p:spPr>
+            <p:txBody>
+              <a:bodyPr/>
+              <a:lstStyle/>
+              <a:p>
+                <a:endParaRPr lang="en-US"/>
+              </a:p>
+            </p:txBody>
           </p:sp>
           <p:sp>
             <p:nvSpPr>
@@ -15506,6 +16519,13 @@
                 </a:solidFill>
               </a:ln>
             </p:spPr>
+            <p:txBody>
+              <a:bodyPr/>
+              <a:lstStyle/>
+              <a:p>
+                <a:endParaRPr lang="en-US"/>
+              </a:p>
+            </p:txBody>
           </p:sp>
         </p:grpSp>
         <p:grpSp>
@@ -15945,6 +16965,13 @@
               <a:tailEnd type="triangle" w="lg" len="lg"/>
             </a:ln>
           </p:spPr>
+          <p:txBody>
+            <a:bodyPr/>
+            <a:lstStyle/>
+            <a:p>
+              <a:endParaRPr lang="en-US"/>
+            </a:p>
+          </p:txBody>
         </p:sp>
         <p:sp>
           <p:nvSpPr>
@@ -15968,6 +16995,13 @@
               <a:tailEnd type="triangle" w="lg" len="lg"/>
             </a:ln>
           </p:spPr>
+          <p:txBody>
+            <a:bodyPr/>
+            <a:lstStyle/>
+            <a:p>
+              <a:endParaRPr lang="en-US"/>
+            </a:p>
+          </p:txBody>
         </p:sp>
         <p:sp>
           <p:nvSpPr>
@@ -15991,6 +17025,13 @@
               <a:tailEnd type="triangle" w="lg" len="lg"/>
             </a:ln>
           </p:spPr>
+          <p:txBody>
+            <a:bodyPr/>
+            <a:lstStyle/>
+            <a:p>
+              <a:endParaRPr lang="en-US"/>
+            </a:p>
+          </p:txBody>
         </p:sp>
         <p:sp>
           <p:nvSpPr>
@@ -16014,6 +17055,13 @@
               <a:tailEnd type="triangle" w="lg" len="lg"/>
             </a:ln>
           </p:spPr>
+          <p:txBody>
+            <a:bodyPr/>
+            <a:lstStyle/>
+            <a:p>
+              <a:endParaRPr lang="en-US"/>
+            </a:p>
+          </p:txBody>
         </p:sp>
         <p:sp>
           <p:nvSpPr>
@@ -16037,6 +17085,13 @@
               <a:tailEnd type="triangle" w="lg" len="lg"/>
             </a:ln>
           </p:spPr>
+          <p:txBody>
+            <a:bodyPr/>
+            <a:lstStyle/>
+            <a:p>
+              <a:endParaRPr lang="en-US"/>
+            </a:p>
+          </p:txBody>
         </p:sp>
       </p:grpSp>
       <p:grpSp>
@@ -16139,9 +17194,18 @@
   <p:clrMapOvr>
     <a:masterClrMapping/>
   </p:clrMapOvr>
-  <p:transition xmlns:p14="http://schemas.microsoft.com/office/powerpoint/2010/main" p14:dur="400">
-    <p:fade/>
-  </p:transition>
+  <mc:AlternateContent xmlns:mc="http://schemas.openxmlformats.org/markup-compatibility/2006">
+    <mc:Choice xmlns:p14="http://schemas.microsoft.com/office/powerpoint/2010/main" Requires="p14">
+      <p:transition p14:dur="400">
+        <p:fade/>
+      </p:transition>
+    </mc:Choice>
+    <mc:Fallback>
+      <p:transition>
+        <p:fade/>
+      </p:transition>
+    </mc:Fallback>
+  </mc:AlternateContent>
 </p:sld>
 </file>
 
@@ -16280,13 +17344,31 @@
         <a:graphic>
           <a:graphicData uri="http://schemas.openxmlformats.org/drawingml/2006/table">
             <a:tbl>
-              <a:tblPr firstRow="1" bandRow="0">
+              <a:tblPr firstRow="1">
                 <a:tableStyleId>{5C22544A-7EE6-4342-B048-85BDC9FD1C3A}</a:tableStyleId>
               </a:tblPr>
               <a:tblGrid>
-                <a:gridCol w="2310064"/>
-                <a:gridCol w="4042610"/>
-                <a:gridCol w="4620126"/>
+                <a:gridCol w="2310064">
+                  <a:extLst>
+                    <a:ext uri="{9D8B030D-6E8A-4147-A177-3AD203B41FA5}">
+                      <a16:colId xmlns:a16="http://schemas.microsoft.com/office/drawing/2014/main" val="20000"/>
+                    </a:ext>
+                  </a:extLst>
+                </a:gridCol>
+                <a:gridCol w="4042610">
+                  <a:extLst>
+                    <a:ext uri="{9D8B030D-6E8A-4147-A177-3AD203B41FA5}">
+                      <a16:colId xmlns:a16="http://schemas.microsoft.com/office/drawing/2014/main" val="20001"/>
+                    </a:ext>
+                  </a:extLst>
+                </a:gridCol>
+                <a:gridCol w="4620126">
+                  <a:extLst>
+                    <a:ext uri="{9D8B030D-6E8A-4147-A177-3AD203B41FA5}">
+                      <a16:colId xmlns:a16="http://schemas.microsoft.com/office/drawing/2014/main" val="20002"/>
+                    </a:ext>
+                  </a:extLst>
+                </a:gridCol>
               </a:tblGrid>
               <a:tr h="419100">
                 <a:tc>
@@ -16436,6 +17518,11 @@
                     </a:solidFill>
                   </a:tcPr>
                 </a:tc>
+                <a:extLst>
+                  <a:ext uri="{0D108BD9-81ED-4DB2-BD59-A6C34878D82A}">
+                    <a16:rowId xmlns:a16="http://schemas.microsoft.com/office/drawing/2014/main" val="10000"/>
+                  </a:ext>
+                </a:extLst>
               </a:tr>
               <a:tr h="419100">
                 <a:tc>
@@ -16443,7 +17530,6 @@
                     <a:bodyPr/>
                     <a:lstStyle/>
                     <a:p>
-                      <a:pPr/>
                       <a:r>
                         <a:rPr lang="en-US" sz="1350" b="0">
                           <a:solidFill>
@@ -16492,7 +17578,6 @@
                     <a:bodyPr/>
                     <a:lstStyle/>
                     <a:p>
-                      <a:pPr/>
                       <a:r>
                         <a:rPr lang="en-US" sz="1350" b="0">
                           <a:solidFill>
@@ -16541,7 +17626,6 @@
                     <a:bodyPr/>
                     <a:lstStyle/>
                     <a:p>
-                      <a:pPr/>
                       <a:r>
                         <a:rPr lang="en-US" sz="1350" b="0">
                           <a:solidFill>
@@ -16585,6 +17669,11 @@
                     </a:solidFill>
                   </a:tcPr>
                 </a:tc>
+                <a:extLst>
+                  <a:ext uri="{0D108BD9-81ED-4DB2-BD59-A6C34878D82A}">
+                    <a16:rowId xmlns:a16="http://schemas.microsoft.com/office/drawing/2014/main" val="10001"/>
+                  </a:ext>
+                </a:extLst>
               </a:tr>
               <a:tr h="419100">
                 <a:tc>
@@ -16592,7 +17681,6 @@
                     <a:bodyPr/>
                     <a:lstStyle/>
                     <a:p>
-                      <a:pPr/>
                       <a:r>
                         <a:rPr lang="en-US" sz="1350" b="0">
                           <a:solidFill>
@@ -16641,7 +17729,6 @@
                     <a:bodyPr/>
                     <a:lstStyle/>
                     <a:p>
-                      <a:pPr/>
                       <a:r>
                         <a:rPr lang="en-US" sz="1350" b="0">
                           <a:solidFill>
@@ -16690,7 +17777,6 @@
                     <a:bodyPr/>
                     <a:lstStyle/>
                     <a:p>
-                      <a:pPr/>
                       <a:r>
                         <a:rPr lang="en-US" sz="1350" b="0">
                           <a:solidFill>
@@ -16734,6 +17820,11 @@
                     </a:solidFill>
                   </a:tcPr>
                 </a:tc>
+                <a:extLst>
+                  <a:ext uri="{0D108BD9-81ED-4DB2-BD59-A6C34878D82A}">
+                    <a16:rowId xmlns:a16="http://schemas.microsoft.com/office/drawing/2014/main" val="10002"/>
+                  </a:ext>
+                </a:extLst>
               </a:tr>
               <a:tr h="419100">
                 <a:tc>
@@ -16741,7 +17832,6 @@
                     <a:bodyPr/>
                     <a:lstStyle/>
                     <a:p>
-                      <a:pPr/>
                       <a:r>
                         <a:rPr lang="en-US" sz="1350" b="0">
                           <a:solidFill>
@@ -16790,7 +17880,6 @@
                     <a:bodyPr/>
                     <a:lstStyle/>
                     <a:p>
-                      <a:pPr/>
                       <a:r>
                         <a:rPr lang="en-US" sz="1350" b="0">
                           <a:solidFill>
@@ -16839,7 +17928,6 @@
                     <a:bodyPr/>
                     <a:lstStyle/>
                     <a:p>
-                      <a:pPr/>
                       <a:r>
                         <a:rPr lang="en-US" sz="1350" b="0">
                           <a:solidFill>
@@ -16883,6 +17971,11 @@
                     </a:solidFill>
                   </a:tcPr>
                 </a:tc>
+                <a:extLst>
+                  <a:ext uri="{0D108BD9-81ED-4DB2-BD59-A6C34878D82A}">
+                    <a16:rowId xmlns:a16="http://schemas.microsoft.com/office/drawing/2014/main" val="10003"/>
+                  </a:ext>
+                </a:extLst>
               </a:tr>
               <a:tr h="419100">
                 <a:tc>
@@ -16890,7 +17983,6 @@
                     <a:bodyPr/>
                     <a:lstStyle/>
                     <a:p>
-                      <a:pPr/>
                       <a:r>
                         <a:rPr lang="en-US" sz="1350" b="0">
                           <a:solidFill>
@@ -16939,7 +18031,6 @@
                     <a:bodyPr/>
                     <a:lstStyle/>
                     <a:p>
-                      <a:pPr/>
                       <a:r>
                         <a:rPr lang="en-US" sz="1350" b="0">
                           <a:solidFill>
@@ -16988,7 +18079,6 @@
                     <a:bodyPr/>
                     <a:lstStyle/>
                     <a:p>
-                      <a:pPr/>
                       <a:r>
                         <a:rPr lang="en-US" sz="1350" b="0">
                           <a:solidFill>
@@ -17032,6 +18122,11 @@
                     </a:solidFill>
                   </a:tcPr>
                 </a:tc>
+                <a:extLst>
+                  <a:ext uri="{0D108BD9-81ED-4DB2-BD59-A6C34878D82A}">
+                    <a16:rowId xmlns:a16="http://schemas.microsoft.com/office/drawing/2014/main" val="10004"/>
+                  </a:ext>
+                </a:extLst>
               </a:tr>
               <a:tr h="419100">
                 <a:tc>
@@ -17039,7 +18134,6 @@
                     <a:bodyPr/>
                     <a:lstStyle/>
                     <a:p>
-                      <a:pPr/>
                       <a:r>
                         <a:rPr lang="en-US" sz="1350" b="0">
                           <a:solidFill>
@@ -17088,7 +18182,6 @@
                     <a:bodyPr/>
                     <a:lstStyle/>
                     <a:p>
-                      <a:pPr/>
                       <a:r>
                         <a:rPr lang="en-US" sz="1350" b="0">
                           <a:solidFill>
@@ -17137,7 +18230,6 @@
                     <a:bodyPr/>
                     <a:lstStyle/>
                     <a:p>
-                      <a:pPr/>
                       <a:r>
                         <a:rPr lang="en-US" sz="1350" b="0">
                           <a:solidFill>
@@ -17181,6 +18273,11 @@
                     </a:solidFill>
                   </a:tcPr>
                 </a:tc>
+                <a:extLst>
+                  <a:ext uri="{0D108BD9-81ED-4DB2-BD59-A6C34878D82A}">
+                    <a16:rowId xmlns:a16="http://schemas.microsoft.com/office/drawing/2014/main" val="10005"/>
+                  </a:ext>
+                </a:extLst>
               </a:tr>
               <a:tr h="419100">
                 <a:tc>
@@ -17188,7 +18285,6 @@
                     <a:bodyPr/>
                     <a:lstStyle/>
                     <a:p>
-                      <a:pPr/>
                       <a:r>
                         <a:rPr lang="en-US" sz="1350" b="0">
                           <a:solidFill>
@@ -17237,7 +18333,6 @@
                     <a:bodyPr/>
                     <a:lstStyle/>
                     <a:p>
-                      <a:pPr/>
                       <a:r>
                         <a:rPr lang="en-US" sz="1350" b="0">
                           <a:solidFill>
@@ -17286,7 +18381,6 @@
                     <a:bodyPr/>
                     <a:lstStyle/>
                     <a:p>
-                      <a:pPr/>
                       <a:r>
                         <a:rPr lang="en-US" sz="1350" b="0">
                           <a:solidFill>
@@ -17330,6 +18424,11 @@
                     </a:solidFill>
                   </a:tcPr>
                 </a:tc>
+                <a:extLst>
+                  <a:ext uri="{0D108BD9-81ED-4DB2-BD59-A6C34878D82A}">
+                    <a16:rowId xmlns:a16="http://schemas.microsoft.com/office/drawing/2014/main" val="10006"/>
+                  </a:ext>
+                </a:extLst>
               </a:tr>
               <a:tr h="419100">
                 <a:tc>
@@ -17337,7 +18436,6 @@
                     <a:bodyPr/>
                     <a:lstStyle/>
                     <a:p>
-                      <a:pPr/>
                       <a:r>
                         <a:rPr lang="en-US" sz="1350" b="0">
                           <a:solidFill>
@@ -17386,7 +18484,6 @@
                     <a:bodyPr/>
                     <a:lstStyle/>
                     <a:p>
-                      <a:pPr/>
                       <a:r>
                         <a:rPr lang="en-US" sz="1350" b="0">
                           <a:solidFill>
@@ -17435,7 +18532,6 @@
                     <a:bodyPr/>
                     <a:lstStyle/>
                     <a:p>
-                      <a:pPr/>
                       <a:r>
                         <a:rPr lang="en-US" sz="1350" b="0">
                           <a:solidFill>
@@ -17479,6 +18575,11 @@
                     </a:solidFill>
                   </a:tcPr>
                 </a:tc>
+                <a:extLst>
+                  <a:ext uri="{0D108BD9-81ED-4DB2-BD59-A6C34878D82A}">
+                    <a16:rowId xmlns:a16="http://schemas.microsoft.com/office/drawing/2014/main" val="10007"/>
+                  </a:ext>
+                </a:extLst>
               </a:tr>
               <a:tr h="419100">
                 <a:tc>
@@ -17486,7 +18587,6 @@
                     <a:bodyPr/>
                     <a:lstStyle/>
                     <a:p>
-                      <a:pPr/>
                       <a:r>
                         <a:rPr lang="en-US" sz="1350" b="0">
                           <a:solidFill>
@@ -17535,7 +18635,6 @@
                     <a:bodyPr/>
                     <a:lstStyle/>
                     <a:p>
-                      <a:pPr/>
                       <a:r>
                         <a:rPr lang="en-US" sz="1350" b="0">
                           <a:solidFill>
@@ -17584,7 +18683,6 @@
                     <a:bodyPr/>
                     <a:lstStyle/>
                     <a:p>
-                      <a:pPr/>
                       <a:r>
                         <a:rPr lang="en-US" sz="1350" b="0">
                           <a:solidFill>
@@ -17628,6 +18726,11 @@
                     </a:solidFill>
                   </a:tcPr>
                 </a:tc>
+                <a:extLst>
+                  <a:ext uri="{0D108BD9-81ED-4DB2-BD59-A6C34878D82A}">
+                    <a16:rowId xmlns:a16="http://schemas.microsoft.com/office/drawing/2014/main" val="10008"/>
+                  </a:ext>
+                </a:extLst>
               </a:tr>
               <a:tr h="419100">
                 <a:tc>
@@ -17635,7 +18738,6 @@
                     <a:bodyPr/>
                     <a:lstStyle/>
                     <a:p>
-                      <a:pPr/>
                       <a:r>
                         <a:rPr lang="en-US" sz="1350" b="0">
                           <a:solidFill>
@@ -17684,7 +18786,6 @@
                     <a:bodyPr/>
                     <a:lstStyle/>
                     <a:p>
-                      <a:pPr/>
                       <a:r>
                         <a:rPr lang="en-US" sz="1350" b="0">
                           <a:solidFill>
@@ -17733,7 +18834,6 @@
                     <a:bodyPr/>
                     <a:lstStyle/>
                     <a:p>
-                      <a:pPr/>
                       <a:r>
                         <a:rPr lang="en-US" sz="1350" b="0">
                           <a:solidFill>
@@ -17777,6 +18877,11 @@
                     </a:solidFill>
                   </a:tcPr>
                 </a:tc>
+                <a:extLst>
+                  <a:ext uri="{0D108BD9-81ED-4DB2-BD59-A6C34878D82A}">
+                    <a16:rowId xmlns:a16="http://schemas.microsoft.com/office/drawing/2014/main" val="10009"/>
+                  </a:ext>
+                </a:extLst>
               </a:tr>
             </a:tbl>
           </a:graphicData>
@@ -17882,9 +18987,18 @@
   <p:clrMapOvr>
     <a:masterClrMapping/>
   </p:clrMapOvr>
-  <p:transition xmlns:p14="http://schemas.microsoft.com/office/powerpoint/2010/main" p14:dur="400">
-    <p:fade/>
-  </p:transition>
+  <mc:AlternateContent xmlns:mc="http://schemas.openxmlformats.org/markup-compatibility/2006">
+    <mc:Choice xmlns:p14="http://schemas.microsoft.com/office/powerpoint/2010/main" Requires="p14">
+      <p:transition p14:dur="400">
+        <p:fade/>
+      </p:transition>
+    </mc:Choice>
+    <mc:Fallback>
+      <p:transition>
+        <p:fade/>
+      </p:transition>
+    </mc:Fallback>
+  </mc:AlternateContent>
 </p:sld>
 </file>
 
@@ -18057,6 +19171,13 @@
               </a:solidFill>
             </a:ln>
           </p:spPr>
+          <p:txBody>
+            <a:bodyPr/>
+            <a:lstStyle/>
+            <a:p>
+              <a:endParaRPr lang="en-US"/>
+            </a:p>
+          </p:txBody>
         </p:sp>
         <p:grpSp>
           <p:nvGrpSpPr>
@@ -18097,6 +19218,13 @@
                 </a:solidFill>
               </a:ln>
             </p:spPr>
+            <p:txBody>
+              <a:bodyPr/>
+              <a:lstStyle/>
+              <a:p>
+                <a:endParaRPr lang="en-US"/>
+              </a:p>
+            </p:txBody>
           </p:sp>
           <p:sp>
             <p:nvSpPr>
@@ -18123,6 +19251,13 @@
                 </a:solidFill>
               </a:ln>
             </p:spPr>
+            <p:txBody>
+              <a:bodyPr/>
+              <a:lstStyle/>
+              <a:p>
+                <a:endParaRPr lang="en-US"/>
+              </a:p>
+            </p:txBody>
           </p:sp>
           <p:sp>
             <p:nvSpPr>
@@ -18149,6 +19284,13 @@
                 </a:solidFill>
               </a:ln>
             </p:spPr>
+            <p:txBody>
+              <a:bodyPr/>
+              <a:lstStyle/>
+              <a:p>
+                <a:endParaRPr lang="en-US"/>
+              </a:p>
+            </p:txBody>
           </p:sp>
           <p:sp>
             <p:nvSpPr>
@@ -18175,6 +19317,13 @@
                 </a:solidFill>
               </a:ln>
             </p:spPr>
+            <p:txBody>
+              <a:bodyPr/>
+              <a:lstStyle/>
+              <a:p>
+                <a:endParaRPr lang="en-US"/>
+              </a:p>
+            </p:txBody>
           </p:sp>
           <p:sp>
             <p:nvSpPr>
@@ -18201,6 +19350,13 @@
                 </a:solidFill>
               </a:ln>
             </p:spPr>
+            <p:txBody>
+              <a:bodyPr/>
+              <a:lstStyle/>
+              <a:p>
+                <a:endParaRPr lang="en-US"/>
+              </a:p>
+            </p:txBody>
           </p:sp>
         </p:grpSp>
         <p:grpSp>
@@ -18416,131 +19572,6 @@
                 </a:r>
               </a:p>
             </p:txBody>
-          </p:sp>
-        </p:grpSp>
-        <p:grpSp>
-          <p:nvGrpSpPr>
-            <p:cNvPr id="23" name="Group 23"/>
-            <p:cNvGrpSpPr/>
-            <p:nvPr/>
-          </p:nvGrpSpPr>
-          <p:grpSpPr>
-            <a:xfrm>
-              <a:off x="1981200" y="3676650"/>
-              <a:ext cx="8229600" cy="228600"/>
-              <a:chOff x="1981200" y="3676650"/>
-              <a:chExt cx="8229600" cy="228600"/>
-            </a:xfrm>
-          </p:grpSpPr>
-          <p:sp>
-            <p:nvSpPr>
-              <p:cNvPr id="18" name="Rectangle 18"/>
-              <p:cNvSpPr/>
-              <p:nvPr/>
-            </p:nvSpPr>
-            <p:spPr>
-              <a:xfrm>
-                <a:off x="1981200" y="3676650"/>
-                <a:ext cx="228600" cy="228600"/>
-              </a:xfrm>
-              <a:prstGeom prst="rect">
-                <a:avLst/>
-              </a:prstGeom>
-              <a:solidFill>
-                <a:schemeClr val="accent2"/>
-              </a:solidFill>
-              <a:ln>
-                <a:noFill/>
-              </a:ln>
-            </p:spPr>
-          </p:sp>
-          <p:sp>
-            <p:nvSpPr>
-              <p:cNvPr id="19" name="Rectangle 19"/>
-              <p:cNvSpPr/>
-              <p:nvPr/>
-            </p:nvSpPr>
-            <p:spPr>
-              <a:xfrm>
-                <a:off x="3981450" y="3676650"/>
-                <a:ext cx="228600" cy="228600"/>
-              </a:xfrm>
-              <a:prstGeom prst="rect">
-                <a:avLst/>
-              </a:prstGeom>
-              <a:solidFill>
-                <a:schemeClr val="accent2"/>
-              </a:solidFill>
-              <a:ln>
-                <a:noFill/>
-              </a:ln>
-            </p:spPr>
-          </p:sp>
-          <p:sp>
-            <p:nvSpPr>
-              <p:cNvPr id="20" name="Rectangle 20"/>
-              <p:cNvSpPr/>
-              <p:nvPr/>
-            </p:nvSpPr>
-            <p:spPr>
-              <a:xfrm>
-                <a:off x="5981700" y="3676650"/>
-                <a:ext cx="228600" cy="228600"/>
-              </a:xfrm>
-              <a:prstGeom prst="rect">
-                <a:avLst/>
-              </a:prstGeom>
-              <a:solidFill>
-                <a:schemeClr val="accent2"/>
-              </a:solidFill>
-              <a:ln>
-                <a:noFill/>
-              </a:ln>
-            </p:spPr>
-          </p:sp>
-          <p:sp>
-            <p:nvSpPr>
-              <p:cNvPr id="21" name="Rectangle 21"/>
-              <p:cNvSpPr/>
-              <p:nvPr/>
-            </p:nvSpPr>
-            <p:spPr>
-              <a:xfrm>
-                <a:off x="7981950" y="3676650"/>
-                <a:ext cx="228600" cy="228600"/>
-              </a:xfrm>
-              <a:prstGeom prst="rect">
-                <a:avLst/>
-              </a:prstGeom>
-              <a:solidFill>
-                <a:schemeClr val="accent2"/>
-              </a:solidFill>
-              <a:ln>
-                <a:noFill/>
-              </a:ln>
-            </p:spPr>
-          </p:sp>
-          <p:sp>
-            <p:nvSpPr>
-              <p:cNvPr id="22" name="Rectangle 22"/>
-              <p:cNvSpPr/>
-              <p:nvPr/>
-            </p:nvSpPr>
-            <p:spPr>
-              <a:xfrm>
-                <a:off x="9982200" y="3676650"/>
-                <a:ext cx="228600" cy="228600"/>
-              </a:xfrm>
-              <a:prstGeom prst="rect">
-                <a:avLst/>
-              </a:prstGeom>
-              <a:solidFill>
-                <a:schemeClr val="accent2"/>
-              </a:solidFill>
-              <a:ln>
-                <a:noFill/>
-              </a:ln>
-            </p:spPr>
           </p:sp>
         </p:grpSp>
       </p:grpSp>
@@ -18684,9 +19715,18 @@
   <p:clrMapOvr>
     <a:masterClrMapping/>
   </p:clrMapOvr>
-  <p:transition xmlns:p14="http://schemas.microsoft.com/office/powerpoint/2010/main" p14:dur="400">
-    <p:fade/>
-  </p:transition>
+  <mc:AlternateContent xmlns:mc="http://schemas.openxmlformats.org/markup-compatibility/2006">
+    <mc:Choice xmlns:p14="http://schemas.microsoft.com/office/powerpoint/2010/main" Requires="p14">
+      <p:transition p14:dur="400">
+        <p:fade/>
+      </p:transition>
+    </mc:Choice>
+    <mc:Fallback>
+      <p:transition>
+        <p:fade/>
+      </p:transition>
+    </mc:Fallback>
+  </mc:AlternateContent>
 </p:sld>
 </file>
 
@@ -18864,6 +19904,13 @@
               <a:tailEnd type="triangle" w="lg" len="lg"/>
             </a:ln>
           </p:spPr>
+          <p:txBody>
+            <a:bodyPr/>
+            <a:lstStyle/>
+            <a:p>
+              <a:endParaRPr lang="en-US"/>
+            </a:p>
+          </p:txBody>
         </p:sp>
         <p:grpSp>
           <p:nvGrpSpPr>
@@ -18902,6 +19949,13 @@
                 </a:solidFill>
               </a:ln>
             </p:spPr>
+            <p:txBody>
+              <a:bodyPr/>
+              <a:lstStyle/>
+              <a:p>
+                <a:endParaRPr lang="en-US"/>
+              </a:p>
+            </p:txBody>
           </p:sp>
           <p:sp>
             <p:nvSpPr>
@@ -18926,6 +19980,13 @@
                 </a:solidFill>
               </a:ln>
             </p:spPr>
+            <p:txBody>
+              <a:bodyPr/>
+              <a:lstStyle/>
+              <a:p>
+                <a:endParaRPr lang="en-US"/>
+              </a:p>
+            </p:txBody>
           </p:sp>
           <p:sp>
             <p:nvSpPr>
@@ -18950,6 +20011,13 @@
                 </a:solidFill>
               </a:ln>
             </p:spPr>
+            <p:txBody>
+              <a:bodyPr/>
+              <a:lstStyle/>
+              <a:p>
+                <a:endParaRPr lang="en-US"/>
+              </a:p>
+            </p:txBody>
           </p:sp>
         </p:grpSp>
         <p:grpSp>
@@ -19263,6 +20331,13 @@
               <a:tailEnd type="triangle" w="lg" len="lg"/>
             </a:ln>
           </p:spPr>
+          <p:txBody>
+            <a:bodyPr/>
+            <a:lstStyle/>
+            <a:p>
+              <a:endParaRPr lang="en-US"/>
+            </a:p>
+          </p:txBody>
         </p:sp>
         <p:sp>
           <p:nvSpPr>
@@ -19405,9 +20480,18 @@
   <p:clrMapOvr>
     <a:masterClrMapping/>
   </p:clrMapOvr>
-  <p:transition xmlns:p14="http://schemas.microsoft.com/office/powerpoint/2010/main" p14:dur="400">
-    <p:fade/>
-  </p:transition>
+  <mc:AlternateContent xmlns:mc="http://schemas.openxmlformats.org/markup-compatibility/2006">
+    <mc:Choice xmlns:p14="http://schemas.microsoft.com/office/powerpoint/2010/main" Requires="p14">
+      <p:transition p14:dur="400">
+        <p:fade/>
+      </p:transition>
+    </mc:Choice>
+    <mc:Fallback>
+      <p:transition>
+        <p:fade/>
+      </p:transition>
+    </mc:Fallback>
+  </mc:AlternateContent>
 </p:sld>
 </file>
 
@@ -19583,6 +20667,13 @@
               <a:tailEnd type="triangle" w="lg" len="lg"/>
             </a:ln>
           </p:spPr>
+          <p:txBody>
+            <a:bodyPr/>
+            <a:lstStyle/>
+            <a:p>
+              <a:endParaRPr lang="en-US"/>
+            </a:p>
+          </p:txBody>
         </p:sp>
         <p:grpSp>
           <p:nvGrpSpPr>
@@ -19623,6 +20714,13 @@
                 </a:solidFill>
               </a:ln>
             </p:spPr>
+            <p:txBody>
+              <a:bodyPr/>
+              <a:lstStyle/>
+              <a:p>
+                <a:endParaRPr lang="en-US"/>
+              </a:p>
+            </p:txBody>
           </p:sp>
           <p:sp>
             <p:nvSpPr>
@@ -19649,6 +20747,13 @@
                 </a:solidFill>
               </a:ln>
             </p:spPr>
+            <p:txBody>
+              <a:bodyPr/>
+              <a:lstStyle/>
+              <a:p>
+                <a:endParaRPr lang="en-US"/>
+              </a:p>
+            </p:txBody>
           </p:sp>
           <p:sp>
             <p:nvSpPr>
@@ -19675,6 +20780,13 @@
                 </a:solidFill>
               </a:ln>
             </p:spPr>
+            <p:txBody>
+              <a:bodyPr/>
+              <a:lstStyle/>
+              <a:p>
+                <a:endParaRPr lang="en-US"/>
+              </a:p>
+            </p:txBody>
           </p:sp>
           <p:sp>
             <p:nvSpPr>
@@ -19701,6 +20813,13 @@
                 </a:solidFill>
               </a:ln>
             </p:spPr>
+            <p:txBody>
+              <a:bodyPr/>
+              <a:lstStyle/>
+              <a:p>
+                <a:endParaRPr lang="en-US"/>
+              </a:p>
+            </p:txBody>
           </p:sp>
           <p:sp>
             <p:nvSpPr>
@@ -19727,6 +20846,13 @@
                 </a:solidFill>
               </a:ln>
             </p:spPr>
+            <p:txBody>
+              <a:bodyPr/>
+              <a:lstStyle/>
+              <a:p>
+                <a:endParaRPr lang="en-US"/>
+              </a:p>
+            </p:txBody>
           </p:sp>
         </p:grpSp>
         <p:grpSp>
@@ -19985,6 +21111,13 @@
               <a:tailEnd type="triangle" w="lg" len="lg"/>
             </a:ln>
           </p:spPr>
+          <p:txBody>
+            <a:bodyPr/>
+            <a:lstStyle/>
+            <a:p>
+              <a:endParaRPr lang="en-US"/>
+            </a:p>
+          </p:txBody>
         </p:sp>
         <p:sp>
           <p:nvSpPr>
@@ -20011,6 +21144,13 @@
               </a:solidFill>
             </a:ln>
           </p:spPr>
+          <p:txBody>
+            <a:bodyPr/>
+            <a:lstStyle/>
+            <a:p>
+              <a:endParaRPr lang="en-US"/>
+            </a:p>
+          </p:txBody>
         </p:sp>
         <p:sp>
           <p:nvSpPr>
@@ -20193,9 +21333,18 @@
   <p:clrMapOvr>
     <a:masterClrMapping/>
   </p:clrMapOvr>
-  <p:transition xmlns:p14="http://schemas.microsoft.com/office/powerpoint/2010/main" p14:dur="400">
-    <p:fade/>
-  </p:transition>
+  <mc:AlternateContent xmlns:mc="http://schemas.openxmlformats.org/markup-compatibility/2006">
+    <mc:Choice xmlns:p14="http://schemas.microsoft.com/office/powerpoint/2010/main" Requires="p14">
+      <p:transition p14:dur="400">
+        <p:fade/>
+      </p:transition>
+    </mc:Choice>
+    <mc:Fallback>
+      <p:transition>
+        <p:fade/>
+      </p:transition>
+    </mc:Fallback>
+  </mc:AlternateContent>
 </p:sld>
 </file>
 
@@ -20837,4 +21986,10 @@
   </a:objectDefaults>
   <a:extraClrSchemeLst/>
 </a:theme>
+</file>
+
+<file path=docMetadata/LabelInfo.xml><?xml version="1.0" encoding="utf-8"?>
+<clbl:labelList xmlns:clbl="http://schemas.microsoft.com/office/2020/mipLabelMetadata">
+  <clbl:label id="{f42aa342-8706-4288-bd11-ebb85995028c}" enabled="1" method="Standard" siteId="{72f988bf-86f1-41af-91ab-2d7cd011db47}" contentBits="0" removed="0"/>
+</clbl:labelList>
 </file>
</xml_diff>